<commit_message>
Polish Montgomery crash safety portfolio
</commit_message>
<xml_diff>
--- a/deliverables/montgomery_crash_safety_presentation.pptx
+++ b/deliverables/montgomery_crash_safety_presentation.pptx
@@ -20424,82 +20424,26 @@
       </p:sp>
       <p:pic>
         <p:nvPicPr>
-          <p:cNvPr id="1026" name="Picture 2" descr="A graph of a bar chart&#10;&#10;AI-generated content may be incorrect.">
-            <a:extLst>
-              <a:ext uri="{FF2B5EF4-FFF2-40B4-BE49-F238E27FC236}">
-                <a16:creationId xmlns:a16="http://schemas.microsoft.com/office/drawing/2014/main" id="{ABC592DF-C7E7-703F-A94E-E09B7A0AFD23}"/>
-              </a:ext>
-            </a:extLst>
-          </p:cNvPr>
-          <p:cNvPicPr>
-            <a:picLocks noChangeAspect="1" noChangeArrowheads="1"/>
-          </p:cNvPicPr>
-          <p:nvPr/>
-        </p:nvPicPr>
-        <p:blipFill>
-          <a:blip r:embed="rId2">
-            <a:extLst>
-              <a:ext uri="{28A0092B-C50C-407E-A947-70E740481C1C}">
-                <a14:useLocalDpi xmlns:a14="http://schemas.microsoft.com/office/drawing/2010/main" val="0"/>
-              </a:ext>
-            </a:extLst>
-          </a:blip>
-          <a:srcRect t="569" r="4" b="4"/>
-          <a:stretch>
-            <a:fillRect/>
-          </a:stretch>
-        </p:blipFill>
-        <p:spPr bwMode="auto">
-          <a:xfrm>
-            <a:off x="713200" y="1177406"/>
-            <a:ext cx="3858775" cy="3433958"/>
-          </a:xfrm>
-          <a:prstGeom prst="rect">
-            <a:avLst/>
-          </a:prstGeom>
-          <a:solidFill>
-            <a:srgbClr val="FFFFFF"/>
-          </a:solidFill>
-          <a:ln>
-            <a:noFill/>
-          </a:ln>
-        </p:spPr>
-      </p:pic>
-      <p:pic>
-        <p:nvPicPr>
-          <p:cNvPr id="4" name="Picture 3" descr="A group of people riding bicycles on a crosswalk&#10;&#10;AI-generated content may be incorrect.">
-            <a:extLst>
-              <a:ext uri="{FF2B5EF4-FFF2-40B4-BE49-F238E27FC236}">
-                <a16:creationId xmlns:a16="http://schemas.microsoft.com/office/drawing/2014/main" id="{C3878E93-D56C-5706-B036-C445F233AE76}"/>
-              </a:ext>
-            </a:extLst>
-          </p:cNvPr>
+          <p:cNvPr id="3" name="Picture 2" descr="image.png"/>
           <p:cNvPicPr>
             <a:picLocks noChangeAspect="1"/>
           </p:cNvPicPr>
           <p:nvPr/>
         </p:nvPicPr>
         <p:blipFill>
-          <a:blip r:embed="rId3"/>
-          <a:srcRect l="16702" r="8289" b="-2"/>
+          <a:blip r:embed="rId4"/>
           <a:stretch>
             <a:fillRect/>
           </a:stretch>
         </p:blipFill>
         <p:spPr>
           <a:xfrm>
-            <a:off x="5148775" y="1434067"/>
-            <a:ext cx="3281950" cy="2920636"/>
+            <a:off x="685800" y="1234440"/>
+            <a:ext cx="10835640" cy="5888803"/>
           </a:xfrm>
           <a:prstGeom prst="rect">
             <a:avLst/>
           </a:prstGeom>
-          <a:noFill/>
-          <a:ln w="19050">
-            <a:solidFill>
-              <a:schemeClr val="accent6"/>
-            </a:solidFill>
-          </a:ln>
         </p:spPr>
       </p:pic>
     </p:spTree>
@@ -20576,86 +20520,6 @@
           </a:p>
         </p:txBody>
       </p:sp>
-      <p:pic>
-        <p:nvPicPr>
-          <p:cNvPr id="2052" name="Picture 4" descr="A graph of a bar chart&#10;&#10;AI-generated content may be incorrect.">
-            <a:extLst>
-              <a:ext uri="{FF2B5EF4-FFF2-40B4-BE49-F238E27FC236}">
-                <a16:creationId xmlns:a16="http://schemas.microsoft.com/office/drawing/2014/main" id="{87747C02-C72B-5B11-9776-ACC2647D3E1B}"/>
-              </a:ext>
-            </a:extLst>
-          </p:cNvPr>
-          <p:cNvPicPr>
-            <a:picLocks noChangeAspect="1" noChangeArrowheads="1"/>
-          </p:cNvPicPr>
-          <p:nvPr/>
-        </p:nvPicPr>
-        <p:blipFill>
-          <a:blip r:embed="rId2">
-            <a:extLst>
-              <a:ext uri="{28A0092B-C50C-407E-A947-70E740481C1C}">
-                <a14:useLocalDpi xmlns:a14="http://schemas.microsoft.com/office/drawing/2010/main" val="0"/>
-              </a:ext>
-            </a:extLst>
-          </a:blip>
-          <a:srcRect r="4" b="850"/>
-          <a:stretch>
-            <a:fillRect/>
-          </a:stretch>
-        </p:blipFill>
-        <p:spPr bwMode="auto">
-          <a:xfrm>
-            <a:off x="713207" y="1208225"/>
-            <a:ext cx="3858768" cy="3433952"/>
-          </a:xfrm>
-          <a:prstGeom prst="rect">
-            <a:avLst/>
-          </a:prstGeom>
-          <a:solidFill>
-            <a:srgbClr val="FFFFFF"/>
-          </a:solidFill>
-          <a:ln>
-            <a:noFill/>
-          </a:ln>
-        </p:spPr>
-      </p:pic>
-      <p:pic>
-        <p:nvPicPr>
-          <p:cNvPr id="5" name="Picture 4" descr="A person sitting in a car with an object in his hand&#10;&#10;AI-generated content may be incorrect.">
-            <a:extLst>
-              <a:ext uri="{FF2B5EF4-FFF2-40B4-BE49-F238E27FC236}">
-                <a16:creationId xmlns:a16="http://schemas.microsoft.com/office/drawing/2014/main" id="{32F78D9E-4541-8BB5-2C15-665FA265D916}"/>
-              </a:ext>
-            </a:extLst>
-          </p:cNvPr>
-          <p:cNvPicPr>
-            <a:picLocks noChangeAspect="1"/>
-          </p:cNvPicPr>
-          <p:nvPr/>
-        </p:nvPicPr>
-        <p:blipFill>
-          <a:blip r:embed="rId3"/>
-          <a:srcRect l="1371" r="23620" b="-2"/>
-          <a:stretch>
-            <a:fillRect/>
-          </a:stretch>
-        </p:blipFill>
-        <p:spPr>
-          <a:xfrm>
-            <a:off x="5152933" y="1466733"/>
-            <a:ext cx="3277792" cy="2916936"/>
-          </a:xfrm>
-          <a:prstGeom prst="rect">
-            <a:avLst/>
-          </a:prstGeom>
-          <a:noFill/>
-          <a:ln w="19050">
-            <a:solidFill>
-              <a:schemeClr val="accent6"/>
-            </a:solidFill>
-          </a:ln>
-        </p:spPr>
-      </p:pic>
       <p:sp>
         <p:nvSpPr>
           <p:cNvPr id="3" name="Rectangle 2">
@@ -20708,6 +20572,30 @@
           </a:p>
         </p:txBody>
       </p:sp>
+      <p:pic>
+        <p:nvPicPr>
+          <p:cNvPr id="4" name="Picture 3" descr="image.png"/>
+          <p:cNvPicPr>
+            <a:picLocks noChangeAspect="1"/>
+          </p:cNvPicPr>
+          <p:nvPr/>
+        </p:nvPicPr>
+        <p:blipFill>
+          <a:blip r:embed="rId4"/>
+          <a:stretch>
+            <a:fillRect/>
+          </a:stretch>
+        </p:blipFill>
+        <p:spPr>
+          <a:xfrm>
+            <a:off x="685800" y="1234440"/>
+            <a:ext cx="10835640" cy="5892107"/>
+          </a:xfrm>
+          <a:prstGeom prst="rect">
+            <a:avLst/>
+          </a:prstGeom>
+        </p:spPr>
+      </p:pic>
     </p:spTree>
     <p:extLst>
       <p:ext uri="{BB962C8B-B14F-4D97-AF65-F5344CB8AC3E}">
@@ -20782,7 +20670,7 @@
                 </a:solidFill>
                 <a:latin typeface="Vidaloka" panose="020B0604020202020204" charset="0"/>
               </a:rPr>
-              <a:t>As Resources Are Limited So As People’s Attention</a:t>
+              <a:t>Limited resources require focused safety investment</a:t>
             </a:r>
           </a:p>
         </p:txBody>
@@ -21199,37 +21087,26 @@
       </p:grpSpPr>
       <p:pic>
         <p:nvPicPr>
-          <p:cNvPr id="4" name="Picture 3">
-            <a:extLst>
-              <a:ext uri="{FF2B5EF4-FFF2-40B4-BE49-F238E27FC236}">
-                <a16:creationId xmlns:a16="http://schemas.microsoft.com/office/drawing/2014/main" id="{6EE50979-7842-F7E8-0DB1-3859158FBED0}"/>
-              </a:ext>
-            </a:extLst>
-          </p:cNvPr>
+          <p:cNvPr id="2" name="Picture 1" descr="image.png"/>
           <p:cNvPicPr>
             <a:picLocks noChangeAspect="1"/>
           </p:cNvPicPr>
           <p:nvPr/>
         </p:nvPicPr>
         <p:blipFill>
-          <a:blip r:embed="rId2"/>
+          <a:blip r:embed="rId3"/>
           <a:stretch>
             <a:fillRect/>
           </a:stretch>
         </p:blipFill>
         <p:spPr>
           <a:xfrm>
-            <a:off x="1852432" y="373242"/>
-            <a:ext cx="5439136" cy="4397016"/>
+            <a:off x="274320" y="640080"/>
+            <a:ext cx="8595360" cy="7780931"/>
           </a:xfrm>
           <a:prstGeom prst="rect">
             <a:avLst/>
           </a:prstGeom>
-          <a:ln w="19050">
-            <a:solidFill>
-              <a:schemeClr val="accent6"/>
-            </a:solidFill>
-          </a:ln>
         </p:spPr>
       </p:pic>
     </p:spTree>
@@ -21375,54 +21252,26 @@
       </p:sp>
       <p:pic>
         <p:nvPicPr>
-          <p:cNvPr id="3074" name="Picture 2">
-            <a:extLst>
-              <a:ext uri="{FF2B5EF4-FFF2-40B4-BE49-F238E27FC236}">
-                <a16:creationId xmlns:a16="http://schemas.microsoft.com/office/drawing/2014/main" id="{F8444BAB-0F4F-B769-1285-EBB7AAEF41D9}"/>
-              </a:ext>
-            </a:extLst>
-          </p:cNvPr>
+          <p:cNvPr id="3" name="Picture 2" descr="image.png"/>
           <p:cNvPicPr>
-            <a:picLocks noChangeAspect="1" noChangeArrowheads="1"/>
+            <a:picLocks noChangeAspect="1"/>
           </p:cNvPicPr>
           <p:nvPr/>
         </p:nvPicPr>
         <p:blipFill>
-          <a:blip r:embed="rId2">
-            <a:extLst>
-              <a:ext uri="{28A0092B-C50C-407E-A947-70E740481C1C}">
-                <a14:useLocalDpi xmlns:a14="http://schemas.microsoft.com/office/drawing/2010/main" val="0"/>
-              </a:ext>
-            </a:extLst>
-          </a:blip>
-          <a:srcRect/>
+          <a:blip r:embed="rId3"/>
           <a:stretch>
             <a:fillRect/>
           </a:stretch>
         </p:blipFill>
-        <p:spPr bwMode="auto">
+        <p:spPr>
           <a:xfrm>
-            <a:off x="4154503" y="492722"/>
-            <a:ext cx="4757380" cy="4158055"/>
+            <a:off x="685800" y="1234440"/>
+            <a:ext cx="10835640" cy="5898728"/>
           </a:xfrm>
           <a:prstGeom prst="rect">
             <a:avLst/>
           </a:prstGeom>
-          <a:noFill/>
-          <a:ln w="19050">
-            <a:solidFill>
-              <a:schemeClr val="accent6"/>
-            </a:solidFill>
-          </a:ln>
-          <a:extLst>
-            <a:ext uri="{909E8E84-426E-40DD-AFC4-6F175D3DCCD1}">
-              <a14:hiddenFill xmlns:a14="http://schemas.microsoft.com/office/drawing/2010/main">
-                <a:solidFill>
-                  <a:srgbClr val="FFFFFF"/>
-                </a:solidFill>
-              </a14:hiddenFill>
-            </a:ext>
-          </a:extLst>
         </p:spPr>
       </p:pic>
     </p:spTree>
@@ -21488,53 +21337,6 @@
           </a:p>
         </p:txBody>
       </p:sp>
-      <p:pic>
-        <p:nvPicPr>
-          <p:cNvPr id="4102" name="Picture 6">
-            <a:extLst>
-              <a:ext uri="{FF2B5EF4-FFF2-40B4-BE49-F238E27FC236}">
-                <a16:creationId xmlns:a16="http://schemas.microsoft.com/office/drawing/2014/main" id="{67135E3F-216D-4CA2-7FEC-F1BB547199F2}"/>
-              </a:ext>
-            </a:extLst>
-          </p:cNvPr>
-          <p:cNvPicPr>
-            <a:picLocks noChangeAspect="1" noChangeArrowheads="1"/>
-          </p:cNvPicPr>
-          <p:nvPr/>
-        </p:nvPicPr>
-        <p:blipFill>
-          <a:blip r:embed="rId2">
-            <a:extLst>
-              <a:ext uri="{28A0092B-C50C-407E-A947-70E740481C1C}">
-                <a14:useLocalDpi xmlns:a14="http://schemas.microsoft.com/office/drawing/2010/main" val="0"/>
-              </a:ext>
-            </a:extLst>
-          </a:blip>
-          <a:srcRect/>
-          <a:stretch>
-            <a:fillRect/>
-          </a:stretch>
-        </p:blipFill>
-        <p:spPr bwMode="auto">
-          <a:xfrm>
-            <a:off x="1090246" y="1017725"/>
-            <a:ext cx="7737231" cy="3825631"/>
-          </a:xfrm>
-          <a:prstGeom prst="rect">
-            <a:avLst/>
-          </a:prstGeom>
-          <a:noFill/>
-          <a:extLst>
-            <a:ext uri="{909E8E84-426E-40DD-AFC4-6F175D3DCCD1}">
-              <a14:hiddenFill xmlns:a14="http://schemas.microsoft.com/office/drawing/2010/main">
-                <a:solidFill>
-                  <a:srgbClr val="FFFFFF"/>
-                </a:solidFill>
-              </a14:hiddenFill>
-            </a:ext>
-          </a:extLst>
-        </p:spPr>
-      </p:pic>
       <p:sp>
         <p:nvSpPr>
           <p:cNvPr id="4" name="Rectangle 3">
@@ -21588,6 +21390,30 @@
           </a:p>
         </p:txBody>
       </p:sp>
+      <p:pic>
+        <p:nvPicPr>
+          <p:cNvPr id="5" name="Picture 4" descr="image.png"/>
+          <p:cNvPicPr>
+            <a:picLocks noChangeAspect="1"/>
+          </p:cNvPicPr>
+          <p:nvPr/>
+        </p:nvPicPr>
+        <p:blipFill>
+          <a:blip r:embed="rId3"/>
+          <a:stretch>
+            <a:fillRect/>
+          </a:stretch>
+        </p:blipFill>
+        <p:spPr>
+          <a:xfrm>
+            <a:off x="685800" y="1234440"/>
+            <a:ext cx="10835640" cy="5627719"/>
+          </a:xfrm>
+          <a:prstGeom prst="rect">
+            <a:avLst/>
+          </a:prstGeom>
+        </p:spPr>
+      </p:pic>
     </p:spTree>
     <p:extLst>
       <p:ext uri="{BB962C8B-B14F-4D97-AF65-F5344CB8AC3E}">
@@ -21742,53 +21568,6 @@
           </a:p>
         </p:txBody>
       </p:sp>
-      <p:pic>
-        <p:nvPicPr>
-          <p:cNvPr id="5130" name="Picture 10">
-            <a:extLst>
-              <a:ext uri="{FF2B5EF4-FFF2-40B4-BE49-F238E27FC236}">
-                <a16:creationId xmlns:a16="http://schemas.microsoft.com/office/drawing/2014/main" id="{F82210AF-5FD1-836F-4A98-FE8A9CC4CBCB}"/>
-              </a:ext>
-            </a:extLst>
-          </p:cNvPr>
-          <p:cNvPicPr>
-            <a:picLocks noChangeAspect="1" noChangeArrowheads="1"/>
-          </p:cNvPicPr>
-          <p:nvPr/>
-        </p:nvPicPr>
-        <p:blipFill>
-          <a:blip r:embed="rId2">
-            <a:extLst>
-              <a:ext uri="{28A0092B-C50C-407E-A947-70E740481C1C}">
-                <a14:useLocalDpi xmlns:a14="http://schemas.microsoft.com/office/drawing/2010/main" val="0"/>
-              </a:ext>
-            </a:extLst>
-          </a:blip>
-          <a:srcRect/>
-          <a:stretch>
-            <a:fillRect/>
-          </a:stretch>
-        </p:blipFill>
-        <p:spPr bwMode="auto">
-          <a:xfrm>
-            <a:off x="713225" y="1027958"/>
-            <a:ext cx="7441809" cy="3670517"/>
-          </a:xfrm>
-          <a:prstGeom prst="rect">
-            <a:avLst/>
-          </a:prstGeom>
-          <a:noFill/>
-          <a:extLst>
-            <a:ext uri="{909E8E84-426E-40DD-AFC4-6F175D3DCCD1}">
-              <a14:hiddenFill xmlns:a14="http://schemas.microsoft.com/office/drawing/2010/main">
-                <a:solidFill>
-                  <a:srgbClr val="FFFFFF"/>
-                </a:solidFill>
-              </a14:hiddenFill>
-            </a:ext>
-          </a:extLst>
-        </p:spPr>
-      </p:pic>
       <p:sp>
         <p:nvSpPr>
           <p:cNvPr id="4" name="Rectangle 3">
@@ -21870,6 +21649,30 @@
           </a:graphicData>
         </a:graphic>
       </p:graphicFrame>
+      <p:pic>
+        <p:nvPicPr>
+          <p:cNvPr id="7" name="Picture 6" descr="image.png"/>
+          <p:cNvPicPr>
+            <a:picLocks noChangeAspect="1"/>
+          </p:cNvPicPr>
+          <p:nvPr/>
+        </p:nvPicPr>
+        <p:blipFill>
+          <a:blip r:embed="rId8"/>
+          <a:stretch>
+            <a:fillRect/>
+          </a:stretch>
+        </p:blipFill>
+        <p:spPr>
+          <a:xfrm>
+            <a:off x="685800" y="1234440"/>
+            <a:ext cx="10835640" cy="5905363"/>
+          </a:xfrm>
+          <a:prstGeom prst="rect">
+            <a:avLst/>
+          </a:prstGeom>
+        </p:spPr>
+      </p:pic>
     </p:spTree>
     <p:extLst>
       <p:ext uri="{BB962C8B-B14F-4D97-AF65-F5344CB8AC3E}">
@@ -23599,7 +23402,7 @@
                 </a:solidFill>
                 <a:latin typeface="Vidaloka" panose="020B0604020202020204" charset="0"/>
               </a:rPr>
-              <a:t>Now We Need to Consider (Equity &amp; Vulnerable Users)</a:t>
+              <a:t>Priority scoring adds equity and vulnerable users</a:t>
             </a:r>
           </a:p>
         </p:txBody>
@@ -23788,22 +23591,7 @@
           <a:lstStyle/>
           <a:p>
             <a:r>
-              <a:rPr lang="en-US" dirty="0">
-                <a:solidFill>
-                  <a:srgbClr val="FF0000"/>
-                </a:solidFill>
-                <a:latin typeface="Vidaloka" panose="020B0604020202020204" charset="0"/>
-              </a:rPr>
-              <a:t>Fatal &amp; severe </a:t>
-            </a:r>
-            <a:r>
-              <a:rPr lang="en-US" dirty="0">
-                <a:solidFill>
-                  <a:schemeClr val="tx1"/>
-                </a:solidFill>
-                <a:latin typeface="Vidaloka" panose="020B0604020202020204" charset="0"/>
-              </a:rPr>
-              <a:t>collisions</a:t>
+              <a:t>KSI crash burden</a:t>
             </a:r>
           </a:p>
         </p:txBody>
@@ -23837,34 +23625,7 @@
           <a:lstStyle/>
           <a:p>
             <a:r>
-              <a:rPr lang="en-US" dirty="0">
-                <a:latin typeface="Vidaloka" panose="020B0604020202020204" charset="0"/>
-              </a:rPr>
-              <a:t>(0.5 x </a:t>
-            </a:r>
-            <a:r>
-              <a:rPr lang="en-US" dirty="0">
-                <a:solidFill>
-                  <a:srgbClr val="FF0000"/>
-                </a:solidFill>
-                <a:latin typeface="Vidaloka" panose="020B0604020202020204" charset="0"/>
-              </a:rPr>
-              <a:t>Fatal </a:t>
-            </a:r>
-            <a:r>
-              <a:rPr lang="en-US" dirty="0">
-                <a:solidFill>
-                  <a:schemeClr val="tx1"/>
-                </a:solidFill>
-                <a:latin typeface="Vidaloka" panose="020B0604020202020204" charset="0"/>
-              </a:rPr>
-              <a:t>collisions</a:t>
-            </a:r>
-            <a:r>
-              <a:rPr lang="en-US" dirty="0">
-                <a:latin typeface="Vidaloka" panose="020B0604020202020204" charset="0"/>
-              </a:rPr>
-              <a:t>)</a:t>
+              <a:t>(1.00 x KSI burden)</a:t>
             </a:r>
           </a:p>
         </p:txBody>
@@ -23898,31 +23659,7 @@
           <a:lstStyle/>
           <a:p>
             <a:r>
-              <a:rPr lang="en-US" dirty="0">
-                <a:solidFill>
-                  <a:schemeClr val="tx1"/>
-                </a:solidFill>
-                <a:latin typeface="Vidaloka" panose="020B0604020202020204" charset="0"/>
-              </a:rPr>
-              <a:t>(0.25 x </a:t>
-            </a:r>
-            <a:r>
-              <a:rPr lang="en-US" dirty="0">
-                <a:solidFill>
-                  <a:srgbClr val="FF0000"/>
-                </a:solidFill>
-                <a:latin typeface="Vidaloka" panose="020B0604020202020204" charset="0"/>
-              </a:rPr>
-              <a:t>Vulnerable Users </a:t>
-            </a:r>
-            <a:r>
-              <a:rPr lang="en-US" dirty="0">
-                <a:solidFill>
-                  <a:schemeClr val="tx1"/>
-                </a:solidFill>
-                <a:latin typeface="Vidaloka" panose="020B0604020202020204" charset="0"/>
-              </a:rPr>
-              <a:t>collisions)  </a:t>
+              <a:t>(0.50 x VRU KSI)</a:t>
             </a:r>
           </a:p>
         </p:txBody>
@@ -23956,48 +23693,7 @@
           <a:lstStyle/>
           <a:p>
             <a:r>
-              <a:rPr lang="en-US" dirty="0">
-                <a:solidFill>
-                  <a:schemeClr val="tx1"/>
-                </a:solidFill>
-                <a:latin typeface="Vidaloka" panose="020B0604020202020204" charset="0"/>
-              </a:rPr>
-              <a:t>(0.25 x </a:t>
-            </a:r>
-            <a:r>
-              <a:rPr lang="en-US" dirty="0">
-                <a:latin typeface="Vidaloka" panose="020B0604020202020204" charset="0"/>
-              </a:rPr>
-              <a:t>Fatal &amp; severe collisions</a:t>
-            </a:r>
-          </a:p>
-          <a:p>
-            <a:r>
-              <a:rPr lang="en-US" dirty="0">
-                <a:solidFill>
-                  <a:schemeClr val="tx1"/>
-                </a:solidFill>
-                <a:latin typeface="Vidaloka" panose="020B0604020202020204" charset="0"/>
-              </a:rPr>
-              <a:t>In </a:t>
-            </a:r>
-            <a:r>
-              <a:rPr lang="en-US" dirty="0">
-                <a:solidFill>
-                  <a:srgbClr val="FF0000"/>
-                </a:solidFill>
-                <a:latin typeface="Vidaloka" panose="020B0604020202020204" charset="0"/>
-              </a:rPr>
-              <a:t>disadvantaged areas</a:t>
-            </a:r>
-            <a:r>
-              <a:rPr lang="en-US" dirty="0">
-                <a:solidFill>
-                  <a:schemeClr val="tx1"/>
-                </a:solidFill>
-                <a:latin typeface="Vidaloka" panose="020B0604020202020204" charset="0"/>
-              </a:rPr>
-              <a:t>)</a:t>
+              <a:t>(0.25 x KSI in disadvantaged tracts)</a:t>
             </a:r>
           </a:p>
         </p:txBody>
@@ -24177,12 +23873,8 @@
           </a:bodyPr>
           <a:lstStyle/>
           <a:p>
-            <a:pPr algn="ctr"/>
             <a:r>
-              <a:rPr lang="en-US" dirty="0">
-                <a:latin typeface="Vidaloka" panose="020B0604020202020204" charset="0"/>
-              </a:rPr>
-              <a:t>Segment length</a:t>
+              <a:t>(0.25 x exposure-adjusted risk)</a:t>
             </a:r>
           </a:p>
         </p:txBody>
@@ -24302,58 +23994,11 @@
           <a:p>
             <a:r>
               <a:rPr lang="en-US" dirty="0"/>
-              <a:t>Top 10 Segments by composite score</a:t>
+              <a:t>Top 10 Segments by CEI-aware priority score</a:t>
             </a:r>
           </a:p>
         </p:txBody>
       </p:sp>
-      <p:pic>
-        <p:nvPicPr>
-          <p:cNvPr id="6152" name="Picture 8">
-            <a:extLst>
-              <a:ext uri="{FF2B5EF4-FFF2-40B4-BE49-F238E27FC236}">
-                <a16:creationId xmlns:a16="http://schemas.microsoft.com/office/drawing/2014/main" id="{1032F073-5CB7-6812-F56E-48876A031E85}"/>
-              </a:ext>
-            </a:extLst>
-          </p:cNvPr>
-          <p:cNvPicPr>
-            <a:picLocks noChangeAspect="1" noChangeArrowheads="1"/>
-          </p:cNvPicPr>
-          <p:nvPr/>
-        </p:nvPicPr>
-        <p:blipFill>
-          <a:blip r:embed="rId2">
-            <a:extLst>
-              <a:ext uri="{28A0092B-C50C-407E-A947-70E740481C1C}">
-                <a14:useLocalDpi xmlns:a14="http://schemas.microsoft.com/office/drawing/2010/main" val="0"/>
-              </a:ext>
-            </a:extLst>
-          </a:blip>
-          <a:srcRect/>
-          <a:stretch>
-            <a:fillRect/>
-          </a:stretch>
-        </p:blipFill>
-        <p:spPr bwMode="auto">
-          <a:xfrm>
-            <a:off x="926329" y="1093337"/>
-            <a:ext cx="7291292" cy="3605138"/>
-          </a:xfrm>
-          <a:prstGeom prst="rect">
-            <a:avLst/>
-          </a:prstGeom>
-          <a:noFill/>
-          <a:extLst>
-            <a:ext uri="{909E8E84-426E-40DD-AFC4-6F175D3DCCD1}">
-              <a14:hiddenFill xmlns:a14="http://schemas.microsoft.com/office/drawing/2010/main">
-                <a:solidFill>
-                  <a:srgbClr val="FFFFFF"/>
-                </a:solidFill>
-              </a14:hiddenFill>
-            </a:ext>
-          </a:extLst>
-        </p:spPr>
-      </p:pic>
       <p:sp>
         <p:nvSpPr>
           <p:cNvPr id="7" name="Rectangle 6">
@@ -24618,6 +24263,30 @@
           </a:p>
         </p:txBody>
       </p:sp>
+      <p:pic>
+        <p:nvPicPr>
+          <p:cNvPr id="8" name="Picture 7" descr="image.png"/>
+          <p:cNvPicPr>
+            <a:picLocks noChangeAspect="1"/>
+          </p:cNvPicPr>
+          <p:nvPr/>
+        </p:nvPicPr>
+        <p:blipFill>
+          <a:blip r:embed="rId3"/>
+          <a:stretch>
+            <a:fillRect/>
+          </a:stretch>
+        </p:blipFill>
+        <p:spPr>
+          <a:xfrm>
+            <a:off x="685800" y="1234440"/>
+            <a:ext cx="10835640" cy="5877164"/>
+          </a:xfrm>
+          <a:prstGeom prst="rect">
+            <a:avLst/>
+          </a:prstGeom>
+        </p:spPr>
+      </p:pic>
     </p:spTree>
     <p:extLst>
       <p:ext uri="{BB962C8B-B14F-4D97-AF65-F5344CB8AC3E}">
@@ -24690,6 +24359,117 @@
           </a:graphicData>
         </a:graphic>
       </p:graphicFrame>
+      <p:sp>
+        <p:nvSpPr>
+          <p:cNvPr id="4" name="TextBox 3"/>
+          <p:cNvSpPr txBox="1"/>
+          <p:nvPr/>
+        </p:nvSpPr>
+        <p:spPr>
+          <a:xfrm>
+            <a:off x="502920" y="228600"/>
+            <a:ext cx="11064240" cy="502920"/>
+          </a:xfrm>
+          <a:prstGeom prst="rect">
+            <a:avLst/>
+          </a:prstGeom>
+          <a:noFill/>
+        </p:spPr>
+        <p:txBody>
+          <a:bodyPr wrap="none">
+            <a:spAutoFit/>
+          </a:bodyPr>
+          <a:lstStyle/>
+          <a:p>
+            <a:r>
+              <a:rPr sz="2400" b="1"/>
+              <a:t>CEI disadvantaged tracts and priority corridors</a:t>
+            </a:r>
+          </a:p>
+        </p:txBody>
+      </p:sp>
+      <p:sp>
+        <p:nvSpPr>
+          <p:cNvPr id="6" name="TextBox 5"/>
+          <p:cNvSpPr txBox="1"/>
+          <p:nvPr/>
+        </p:nvSpPr>
+        <p:spPr>
+          <a:xfrm>
+            <a:off x="502920" y="228600"/>
+            <a:ext cx="11064240" cy="502920"/>
+          </a:xfrm>
+          <a:prstGeom prst="rect">
+            <a:avLst/>
+          </a:prstGeom>
+          <a:noFill/>
+        </p:spPr>
+        <p:txBody>
+          <a:bodyPr wrap="none">
+            <a:spAutoFit/>
+          </a:bodyPr>
+          <a:lstStyle/>
+          <a:p>
+            <a:r>
+              <a:rPr sz="2400" b="1"/>
+              <a:t>CEI disadvantaged tracts and priority corridors</a:t>
+            </a:r>
+          </a:p>
+        </p:txBody>
+      </p:sp>
+      <p:pic>
+        <p:nvPicPr>
+          <p:cNvPr id="7" name="Picture 6" descr="image.png"/>
+          <p:cNvPicPr>
+            <a:picLocks noChangeAspect="1"/>
+          </p:cNvPicPr>
+          <p:nvPr/>
+        </p:nvPicPr>
+        <p:blipFill>
+          <a:blip r:embed="rId7"/>
+          <a:stretch>
+            <a:fillRect/>
+          </a:stretch>
+        </p:blipFill>
+        <p:spPr>
+          <a:xfrm>
+            <a:off x="274320" y="640080"/>
+            <a:ext cx="8595360" cy="7560508"/>
+          </a:xfrm>
+          <a:prstGeom prst="rect">
+            <a:avLst/>
+          </a:prstGeom>
+        </p:spPr>
+      </p:pic>
+      <p:sp>
+        <p:nvSpPr>
+          <p:cNvPr id="8" name="TextBox 7"/>
+          <p:cNvSpPr txBox="1"/>
+          <p:nvPr/>
+        </p:nvSpPr>
+        <p:spPr>
+          <a:xfrm>
+            <a:off x="502920" y="228600"/>
+            <a:ext cx="11064240" cy="502920"/>
+          </a:xfrm>
+          <a:prstGeom prst="rect">
+            <a:avLst/>
+          </a:prstGeom>
+          <a:noFill/>
+        </p:spPr>
+        <p:txBody>
+          <a:bodyPr wrap="none">
+            <a:spAutoFit/>
+          </a:bodyPr>
+          <a:lstStyle/>
+          <a:p>
+            <a:r>
+              <a:rPr sz="2400" b="1"/>
+              <a:t>CEI disadvantaged tracts and priority corridors</a:t>
+            </a:r>
+          </a:p>
+        </p:txBody>
+      </p:sp>
     </p:spTree>
     <p:extLst>
       <p:ext uri="{BB962C8B-B14F-4D97-AF65-F5344CB8AC3E}">
@@ -25012,180 +24792,41 @@
           </a:bodyPr>
           <a:lstStyle/>
           <a:p>
-            <a:pPr marL="285750" indent="-285750">
-              <a:buFont typeface="Arial" panose="020B0604020202020204" pitchFamily="34" charset="0"/>
-              <a:buChar char="•"/>
-            </a:pPr>
             <a:r>
-              <a:rPr lang="en-US" sz="1800" dirty="0">
-                <a:solidFill>
-                  <a:srgbClr val="FF0000"/>
-                </a:solidFill>
-                <a:latin typeface="Vidaloka" panose="020B0604020202020204" charset="0"/>
-              </a:rPr>
-              <a:t>Ensures fairness </a:t>
-            </a:r>
-            <a:r>
-              <a:rPr lang="en-US" sz="1800" dirty="0">
-                <a:latin typeface="Vidaloka" panose="020B0604020202020204" charset="0"/>
-              </a:rPr>
-              <a:t>– not just big arterials, also smaller risky roads</a:t>
+              <a:t>Prioritizes high-harm corridors, including corridors in disadvantaged tracts</a:t>
             </a:r>
           </a:p>
+          <a:p/>
           <a:p>
-            <a:pPr marL="285750" indent="-285750">
-              <a:buFont typeface="Arial" panose="020B0604020202020204" pitchFamily="34" charset="0"/>
-              <a:buChar char="•"/>
-            </a:pPr>
-            <a:endParaRPr lang="en-US" sz="1800" dirty="0">
-              <a:latin typeface="Vidaloka" panose="020B0604020202020204" charset="0"/>
-            </a:endParaRPr>
-          </a:p>
-          <a:p>
-            <a:pPr marL="285750" indent="-285750">
-              <a:buFont typeface="Arial" panose="020B0604020202020204" pitchFamily="34" charset="0"/>
-              <a:buChar char="•"/>
-            </a:pPr>
             <a:r>
-              <a:rPr lang="en-US" sz="1800" dirty="0">
-                <a:solidFill>
-                  <a:srgbClr val="FF0000"/>
-                </a:solidFill>
-                <a:latin typeface="Vidaloka" panose="020B0604020202020204" charset="0"/>
-              </a:rPr>
-              <a:t>Re-score</a:t>
-            </a:r>
-            <a:r>
-              <a:rPr lang="en-US" sz="1800" dirty="0">
-                <a:latin typeface="Vidaloka" panose="020B0604020202020204" charset="0"/>
-              </a:rPr>
-              <a:t> every 2–3 years</a:t>
+              <a:t>Re-score every 2-3 years</a:t>
             </a:r>
           </a:p>
+          <a:p/>
           <a:p>
-            <a:pPr marL="285750" indent="-285750">
-              <a:buFont typeface="Arial" panose="020B0604020202020204" pitchFamily="34" charset="0"/>
-              <a:buChar char="•"/>
-            </a:pPr>
-            <a:endParaRPr lang="en-US" sz="1800" dirty="0">
-              <a:latin typeface="Vidaloka" panose="020B0604020202020204" charset="0"/>
-            </a:endParaRPr>
-          </a:p>
-          <a:p>
-            <a:pPr marL="285750" indent="-285750">
-              <a:buFont typeface="Arial" panose="020B0604020202020204" pitchFamily="34" charset="0"/>
-              <a:buChar char="•"/>
-            </a:pPr>
             <a:r>
-              <a:rPr lang="en-US" sz="1800" dirty="0">
-                <a:latin typeface="Vidaloka" panose="020B0604020202020204" charset="0"/>
-              </a:rPr>
               <a:t>Phased delivery:</a:t>
             </a:r>
           </a:p>
           <a:p>
-            <a:pPr marL="285750" indent="-285750">
-              <a:buFont typeface="Arial" panose="020B0604020202020204" pitchFamily="34" charset="0"/>
-              <a:buChar char="•"/>
-            </a:pPr>
-            <a:endParaRPr lang="en-US" sz="1800" dirty="0">
-              <a:latin typeface="Vidaloka" panose="020B0604020202020204" charset="0"/>
-            </a:endParaRPr>
-          </a:p>
-          <a:p>
-            <a:pPr lvl="1"/>
             <a:r>
-              <a:rPr lang="en-US" sz="1800" dirty="0">
-                <a:solidFill>
-                  <a:srgbClr val="FF0000"/>
-                </a:solidFill>
-                <a:latin typeface="Vidaloka" panose="020B0604020202020204" charset="0"/>
-              </a:rPr>
-              <a:t>	Year 1 </a:t>
-            </a:r>
-            <a:r>
-              <a:rPr lang="en-US" sz="1800" dirty="0">
-                <a:latin typeface="Vidaloka" panose="020B0604020202020204" charset="0"/>
-              </a:rPr>
-              <a:t>→ Quick wins (LPIs, daylighting, pilot road diets)</a:t>
+              <a:t>Year 1: quick wins such as LPIs, daylighting, and pilot road diets</a:t>
             </a:r>
           </a:p>
           <a:p>
-            <a:endParaRPr lang="en-US" sz="1800" dirty="0">
-              <a:latin typeface="Vidaloka" panose="020B0604020202020204" charset="0"/>
-            </a:endParaRPr>
+            <a:r>
+              <a:t>Years 1-3: corridor redesigns</a:t>
+            </a:r>
           </a:p>
           <a:p>
             <a:r>
-              <a:rPr lang="en-US" sz="1800" dirty="0">
-                <a:solidFill>
-                  <a:srgbClr val="FF0000"/>
-                </a:solidFill>
-                <a:latin typeface="Vidaloka" panose="020B0604020202020204" charset="0"/>
-              </a:rPr>
-              <a:t>	Years 1–3 </a:t>
-            </a:r>
-            <a:r>
-              <a:rPr lang="en-US" sz="1800" dirty="0">
-                <a:latin typeface="Vidaloka" panose="020B0604020202020204" charset="0"/>
-              </a:rPr>
-              <a:t>→ Corridor redesigns</a:t>
+              <a:t>Years 3-5: major reconstructions</a:t>
             </a:r>
           </a:p>
-          <a:p>
-            <a:pPr marL="285750" indent="-285750">
-              <a:buFont typeface="Arial" panose="020B0604020202020204" pitchFamily="34" charset="0"/>
-              <a:buChar char="•"/>
-            </a:pPr>
-            <a:endParaRPr lang="en-US" sz="1800" dirty="0">
-              <a:latin typeface="Vidaloka" panose="020B0604020202020204" charset="0"/>
-            </a:endParaRPr>
-          </a:p>
+          <a:p/>
           <a:p>
             <a:r>
-              <a:rPr lang="en-US" sz="1800" dirty="0">
-                <a:solidFill>
-                  <a:srgbClr val="FF0000"/>
-                </a:solidFill>
-                <a:latin typeface="Vidaloka" panose="020B0604020202020204" charset="0"/>
-              </a:rPr>
-              <a:t>	Years 3–5 </a:t>
-            </a:r>
-            <a:r>
-              <a:rPr lang="en-US" sz="1800" dirty="0">
-                <a:latin typeface="Vidaloka" panose="020B0604020202020204" charset="0"/>
-              </a:rPr>
-              <a:t>→ Major reconstructions</a:t>
-            </a:r>
-          </a:p>
-          <a:p>
-            <a:pPr marL="285750" indent="-285750">
-              <a:buFont typeface="Arial" panose="020B0604020202020204" pitchFamily="34" charset="0"/>
-              <a:buChar char="•"/>
-            </a:pPr>
-            <a:endParaRPr lang="en-US" sz="1800" dirty="0">
-              <a:latin typeface="Vidaloka" panose="020B0604020202020204" charset="0"/>
-            </a:endParaRPr>
-          </a:p>
-          <a:p>
-            <a:pPr marL="285750" indent="-285750">
-              <a:buFont typeface="Arial" panose="020B0604020202020204" pitchFamily="34" charset="0"/>
-              <a:buChar char="•"/>
-            </a:pPr>
-            <a:r>
-              <a:rPr lang="en-US" sz="1800" dirty="0">
-                <a:solidFill>
-                  <a:srgbClr val="FF0000"/>
-                </a:solidFill>
-                <a:latin typeface="Vidaloka" panose="020B0604020202020204" charset="0"/>
-              </a:rPr>
-              <a:t>Track progress</a:t>
-            </a:r>
-            <a:r>
-              <a:rPr lang="en-US" sz="1800" dirty="0">
-                <a:latin typeface="Vidaloka" panose="020B0604020202020204" charset="0"/>
-              </a:rPr>
-              <a:t>: KSI, HIN share, VRU, equity, cost</a:t>
+              <a:t>Track progress: KSI, HIN share, VRU KSI, CEI contribution, and exposure-adjusted risk</a:t>
             </a:r>
           </a:p>
         </p:txBody>
@@ -25553,7 +25194,7 @@
                   <a:schemeClr val="accent1"/>
                 </a:solidFill>
               </a:rPr>
-              <a:t>Proplem Statement</a:t>
+              <a:t>Problem Statement</a:t>
             </a:r>
             <a:endParaRPr b="1" dirty="0">
               <a:solidFill>
@@ -25820,211 +25461,9 @@
             </a:lvl9pPr>
           </a:lstStyle>
           <a:p>
-            <a:pPr marL="114300">
-              <a:lnSpc>
-                <a:spcPct val="150000"/>
-              </a:lnSpc>
-            </a:pPr>
             <a:r>
-              <a:rPr lang="en-US" sz="1800" dirty="0">
-                <a:latin typeface="Vidaloka" panose="020B0604020202020204" charset="0"/>
-              </a:rPr>
-              <a:t>From </a:t>
+              <a:t>From 2020-2024, Montgomery County recorded 59,476 crashes. Of these, 1,400 were fatal or suspected serious injury crashes (KSI), with an estimated $7.1 billion in societal cost. To reach Vision Zero, the County should focus engineering, enforcement, and policy on the corridors and conditions most strongly linked to severe crashes.</a:t>
             </a:r>
-            <a:r>
-              <a:rPr lang="en-US" sz="1800" b="1" dirty="0">
-                <a:latin typeface="Vidaloka" panose="020B0604020202020204" charset="0"/>
-              </a:rPr>
-              <a:t>2020–2024</a:t>
-            </a:r>
-            <a:r>
-              <a:rPr lang="en-US" sz="1800" dirty="0">
-                <a:latin typeface="Vidaloka" panose="020B0604020202020204" charset="0"/>
-              </a:rPr>
-              <a:t>, Montgomery County recorded </a:t>
-            </a:r>
-            <a:r>
-              <a:rPr lang="en-US" sz="1800" b="1" dirty="0">
-                <a:solidFill>
-                  <a:srgbClr val="FF0000"/>
-                </a:solidFill>
-                <a:latin typeface="Vidaloka" panose="020B0604020202020204" charset="0"/>
-              </a:rPr>
-              <a:t>113K total crashes</a:t>
-            </a:r>
-            <a:r>
-              <a:rPr lang="en-US" sz="1800" dirty="0">
-                <a:latin typeface="Vidaloka" panose="020B0604020202020204" charset="0"/>
-              </a:rPr>
-              <a:t>. Of these,</a:t>
-            </a:r>
-            <a:r>
-              <a:rPr lang="en-US" sz="1800" b="1" dirty="0">
-                <a:latin typeface="Vidaloka" panose="020B0604020202020204" charset="0"/>
-              </a:rPr>
-              <a:t> </a:t>
-            </a:r>
-            <a:r>
-              <a:rPr lang="en-US" sz="1800" b="1" dirty="0">
-                <a:solidFill>
-                  <a:srgbClr val="FF0000"/>
-                </a:solidFill>
-                <a:latin typeface="Vidaloka" panose="020B0604020202020204" charset="0"/>
-              </a:rPr>
-              <a:t>(4K crashes)</a:t>
-            </a:r>
-            <a:r>
-              <a:rPr lang="en-US" sz="1800" dirty="0">
-                <a:solidFill>
-                  <a:srgbClr val="FF0000"/>
-                </a:solidFill>
-                <a:latin typeface="Vidaloka" panose="020B0604020202020204" charset="0"/>
-              </a:rPr>
-              <a:t> </a:t>
-            </a:r>
-            <a:r>
-              <a:rPr lang="en-US" sz="1800" dirty="0">
-                <a:latin typeface="Vidaloka" panose="020B0604020202020204" charset="0"/>
-              </a:rPr>
-              <a:t>involved </a:t>
-            </a:r>
-            <a:r>
-              <a:rPr lang="en-US" sz="1800" b="1" dirty="0">
-                <a:solidFill>
-                  <a:srgbClr val="FF0000"/>
-                </a:solidFill>
-                <a:latin typeface="Vidaloka" panose="020B0604020202020204" charset="0"/>
-              </a:rPr>
-              <a:t>fatalities or serious injuries </a:t>
-            </a:r>
-            <a:r>
-              <a:rPr lang="en-US" sz="1800" dirty="0">
-                <a:latin typeface="Vidaloka" panose="020B0604020202020204" charset="0"/>
-              </a:rPr>
-              <a:t>(</a:t>
-            </a:r>
-            <a:r>
-              <a:rPr lang="en-US" sz="1800" b="1" dirty="0">
-                <a:latin typeface="Vidaloka" panose="020B0604020202020204" charset="0"/>
-              </a:rPr>
-              <a:t>KSI</a:t>
-            </a:r>
-            <a:r>
-              <a:rPr lang="en-US" sz="1800" dirty="0">
-                <a:latin typeface="Vidaloka" panose="020B0604020202020204" charset="0"/>
-              </a:rPr>
-              <a:t>), at an estimated </a:t>
-            </a:r>
-            <a:r>
-              <a:rPr lang="en-US" sz="1800" b="1" dirty="0">
-                <a:solidFill>
-                  <a:srgbClr val="FF0000"/>
-                </a:solidFill>
-                <a:latin typeface="Vidaloka" panose="020B0604020202020204" charset="0"/>
-              </a:rPr>
-              <a:t>$6.3 billion</a:t>
-            </a:r>
-            <a:r>
-              <a:rPr lang="en-US" sz="1800" dirty="0">
-                <a:solidFill>
-                  <a:srgbClr val="FF0000"/>
-                </a:solidFill>
-                <a:latin typeface="Vidaloka" panose="020B0604020202020204" charset="0"/>
-              </a:rPr>
-              <a:t> </a:t>
-            </a:r>
-            <a:r>
-              <a:rPr lang="en-US" sz="1800" dirty="0">
-                <a:latin typeface="Vidaloka" panose="020B0604020202020204" charset="0"/>
-              </a:rPr>
-              <a:t>in societal cost.</a:t>
-            </a:r>
-          </a:p>
-          <a:p>
-            <a:pPr marL="114300">
-              <a:lnSpc>
-                <a:spcPct val="150000"/>
-              </a:lnSpc>
-            </a:pPr>
-            <a:endParaRPr lang="en-US" sz="1800" dirty="0">
-              <a:latin typeface="Vidaloka" panose="020B0604020202020204" charset="0"/>
-            </a:endParaRPr>
-          </a:p>
-          <a:p>
-            <a:pPr marL="114300">
-              <a:lnSpc>
-                <a:spcPct val="150000"/>
-              </a:lnSpc>
-            </a:pPr>
-            <a:r>
-              <a:rPr lang="en-US" sz="1800" dirty="0">
-                <a:latin typeface="Vidaloka" panose="020B0604020202020204" charset="0"/>
-              </a:rPr>
-              <a:t>To reach </a:t>
-            </a:r>
-            <a:r>
-              <a:rPr lang="en-US" sz="1800" b="1" dirty="0">
-                <a:latin typeface="Vidaloka" panose="020B0604020202020204" charset="0"/>
-              </a:rPr>
-              <a:t>Vision Zero</a:t>
-            </a:r>
-            <a:r>
-              <a:rPr lang="en-US" sz="1800" dirty="0">
-                <a:latin typeface="Vidaloka" panose="020B0604020202020204" charset="0"/>
-              </a:rPr>
-              <a:t>, the County must </a:t>
-            </a:r>
-            <a:r>
-              <a:rPr lang="en-US" sz="1800" b="1" dirty="0">
-                <a:latin typeface="Vidaloka" panose="020B0604020202020204" charset="0"/>
-              </a:rPr>
-              <a:t>focus enforcement, engineering, and policy</a:t>
-            </a:r>
-            <a:r>
-              <a:rPr lang="en-US" sz="1800" dirty="0">
-                <a:latin typeface="Vidaloka" panose="020B0604020202020204" charset="0"/>
-              </a:rPr>
-              <a:t> on the </a:t>
-            </a:r>
-            <a:r>
-              <a:rPr lang="en-US" sz="1800" b="1" dirty="0">
-                <a:latin typeface="Vidaloka" panose="020B0604020202020204" charset="0"/>
-              </a:rPr>
-              <a:t>corridors and conditions most strongly linked to severe crashes</a:t>
-            </a:r>
-            <a:r>
-              <a:rPr lang="en-US" sz="1800" dirty="0">
-                <a:latin typeface="Vidaloka" panose="020B0604020202020204" charset="0"/>
-              </a:rPr>
-              <a:t>, to drive down both </a:t>
-            </a:r>
-            <a:r>
-              <a:rPr lang="en-US" sz="1800" b="1" dirty="0">
-                <a:latin typeface="Vidaloka" panose="020B0604020202020204" charset="0"/>
-              </a:rPr>
-              <a:t>lives lost</a:t>
-            </a:r>
-            <a:r>
-              <a:rPr lang="en-US" sz="1800" dirty="0">
-                <a:latin typeface="Vidaloka" panose="020B0604020202020204" charset="0"/>
-              </a:rPr>
-              <a:t> and </a:t>
-            </a:r>
-            <a:r>
-              <a:rPr lang="en-US" sz="1800" b="1" dirty="0">
-                <a:latin typeface="Vidaloka" panose="020B0604020202020204" charset="0"/>
-              </a:rPr>
-              <a:t>economic cost</a:t>
-            </a:r>
-            <a:r>
-              <a:rPr lang="en-US" sz="1800" dirty="0">
-                <a:latin typeface="Vidaloka" panose="020B0604020202020204" charset="0"/>
-              </a:rPr>
-              <a:t>.</a:t>
-            </a:r>
-            <a:endParaRPr lang="en-US" sz="2800" dirty="0">
-              <a:latin typeface="Vidaloka" panose="020B0604020202020204" charset="0"/>
-            </a:endParaRPr>
           </a:p>
         </p:txBody>
       </p:sp>
@@ -26457,53 +25896,6 @@
           </a:p>
         </p:txBody>
       </p:sp>
-      <p:pic>
-        <p:nvPicPr>
-          <p:cNvPr id="20482" name="Picture 2">
-            <a:extLst>
-              <a:ext uri="{FF2B5EF4-FFF2-40B4-BE49-F238E27FC236}">
-                <a16:creationId xmlns:a16="http://schemas.microsoft.com/office/drawing/2014/main" id="{D187E795-6EFC-19C1-D5E0-D6A9E468A5F2}"/>
-              </a:ext>
-            </a:extLst>
-          </p:cNvPr>
-          <p:cNvPicPr>
-            <a:picLocks noChangeAspect="1" noChangeArrowheads="1"/>
-          </p:cNvPicPr>
-          <p:nvPr/>
-        </p:nvPicPr>
-        <p:blipFill>
-          <a:blip r:embed="rId2">
-            <a:extLst>
-              <a:ext uri="{28A0092B-C50C-407E-A947-70E740481C1C}">
-                <a14:useLocalDpi xmlns:a14="http://schemas.microsoft.com/office/drawing/2010/main" val="0"/>
-              </a:ext>
-            </a:extLst>
-          </a:blip>
-          <a:srcRect/>
-          <a:stretch>
-            <a:fillRect/>
-          </a:stretch>
-        </p:blipFill>
-        <p:spPr bwMode="auto">
-          <a:xfrm>
-            <a:off x="0" y="1568450"/>
-            <a:ext cx="9144000" cy="3575050"/>
-          </a:xfrm>
-          <a:prstGeom prst="rect">
-            <a:avLst/>
-          </a:prstGeom>
-          <a:noFill/>
-          <a:extLst>
-            <a:ext uri="{909E8E84-426E-40DD-AFC4-6F175D3DCCD1}">
-              <a14:hiddenFill xmlns:a14="http://schemas.microsoft.com/office/drawing/2010/main">
-                <a:solidFill>
-                  <a:srgbClr val="FFFFFF"/>
-                </a:solidFill>
-              </a14:hiddenFill>
-            </a:ext>
-          </a:extLst>
-        </p:spPr>
-      </p:pic>
       <p:sp>
         <p:nvSpPr>
           <p:cNvPr id="3" name="Rectangle 2">
@@ -26557,6 +25949,30 @@
           </a:p>
         </p:txBody>
       </p:sp>
+      <p:pic>
+        <p:nvPicPr>
+          <p:cNvPr id="4" name="Picture 3" descr="image.png"/>
+          <p:cNvPicPr>
+            <a:picLocks noChangeAspect="1"/>
+          </p:cNvPicPr>
+          <p:nvPr/>
+        </p:nvPicPr>
+        <p:blipFill>
+          <a:blip r:embed="rId3"/>
+          <a:stretch>
+            <a:fillRect/>
+          </a:stretch>
+        </p:blipFill>
+        <p:spPr>
+          <a:xfrm>
+            <a:off x="685800" y="1234440"/>
+            <a:ext cx="10835640" cy="5904815"/>
+          </a:xfrm>
+          <a:prstGeom prst="rect">
+            <a:avLst/>
+          </a:prstGeom>
+        </p:spPr>
+      </p:pic>
     </p:spTree>
     <p:extLst>
       <p:ext uri="{BB962C8B-B14F-4D97-AF65-F5344CB8AC3E}">
@@ -27165,53 +26581,6 @@
           </a:p>
         </p:txBody>
       </p:sp>
-      <p:pic>
-        <p:nvPicPr>
-          <p:cNvPr id="2058" name="Picture 10">
-            <a:extLst>
-              <a:ext uri="{FF2B5EF4-FFF2-40B4-BE49-F238E27FC236}">
-                <a16:creationId xmlns:a16="http://schemas.microsoft.com/office/drawing/2014/main" id="{9EF3A103-545A-96AF-D0C9-FB4A75CC02D0}"/>
-              </a:ext>
-            </a:extLst>
-          </p:cNvPr>
-          <p:cNvPicPr>
-            <a:picLocks noChangeAspect="1" noChangeArrowheads="1"/>
-          </p:cNvPicPr>
-          <p:nvPr/>
-        </p:nvPicPr>
-        <p:blipFill>
-          <a:blip r:embed="rId2">
-            <a:extLst>
-              <a:ext uri="{28A0092B-C50C-407E-A947-70E740481C1C}">
-                <a14:useLocalDpi xmlns:a14="http://schemas.microsoft.com/office/drawing/2010/main" val="0"/>
-              </a:ext>
-            </a:extLst>
-          </a:blip>
-          <a:srcRect/>
-          <a:stretch>
-            <a:fillRect/>
-          </a:stretch>
-        </p:blipFill>
-        <p:spPr bwMode="auto">
-          <a:xfrm>
-            <a:off x="0" y="1374775"/>
-            <a:ext cx="9144000" cy="3768725"/>
-          </a:xfrm>
-          <a:prstGeom prst="rect">
-            <a:avLst/>
-          </a:prstGeom>
-          <a:noFill/>
-          <a:extLst>
-            <a:ext uri="{909E8E84-426E-40DD-AFC4-6F175D3DCCD1}">
-              <a14:hiddenFill xmlns:a14="http://schemas.microsoft.com/office/drawing/2010/main">
-                <a:solidFill>
-                  <a:srgbClr val="FFFFFF"/>
-                </a:solidFill>
-              </a14:hiddenFill>
-            </a:ext>
-          </a:extLst>
-        </p:spPr>
-      </p:pic>
       <p:sp>
         <p:nvSpPr>
           <p:cNvPr id="3" name="Rectangle 2">
@@ -27265,6 +26634,30 @@
           </a:p>
         </p:txBody>
       </p:sp>
+      <p:pic>
+        <p:nvPicPr>
+          <p:cNvPr id="4" name="Picture 3" descr="image.png"/>
+          <p:cNvPicPr>
+            <a:picLocks noChangeAspect="1"/>
+          </p:cNvPicPr>
+          <p:nvPr/>
+        </p:nvPicPr>
+        <p:blipFill>
+          <a:blip r:embed="rId3"/>
+          <a:stretch>
+            <a:fillRect/>
+          </a:stretch>
+        </p:blipFill>
+        <p:spPr>
+          <a:xfrm>
+            <a:off x="685800" y="1234440"/>
+            <a:ext cx="10835640" cy="5892107"/>
+          </a:xfrm>
+          <a:prstGeom prst="rect">
+            <a:avLst/>
+          </a:prstGeom>
+        </p:spPr>
+      </p:pic>
     </p:spTree>
     <p:extLst>
       <p:ext uri="{BB962C8B-B14F-4D97-AF65-F5344CB8AC3E}">

</xml_diff>

<commit_message>
Refresh Montgomery rebuild artifacts
</commit_message>
<xml_diff>
--- a/deliverables/montgomery_crash_safety_presentation.pptx
+++ b/deliverables/montgomery_crash_safety_presentation.pptx
@@ -24417,9 +24417,38 @@
           </a:p>
         </p:txBody>
       </p:sp>
+      <p:sp>
+        <p:nvSpPr>
+          <p:cNvPr id="8" name="TextBox 7"/>
+          <p:cNvSpPr txBox="1"/>
+          <p:nvPr/>
+        </p:nvSpPr>
+        <p:spPr>
+          <a:xfrm>
+            <a:off x="502920" y="228600"/>
+            <a:ext cx="11064240" cy="502920"/>
+          </a:xfrm>
+          <a:prstGeom prst="rect">
+            <a:avLst/>
+          </a:prstGeom>
+          <a:noFill/>
+        </p:spPr>
+        <p:txBody>
+          <a:bodyPr wrap="none">
+            <a:spAutoFit/>
+          </a:bodyPr>
+          <a:lstStyle/>
+          <a:p>
+            <a:r>
+              <a:rPr sz="2400" b="1"/>
+              <a:t>CEI disadvantaged tracts and priority corridors</a:t>
+            </a:r>
+          </a:p>
+        </p:txBody>
+      </p:sp>
       <p:pic>
         <p:nvPicPr>
-          <p:cNvPr id="7" name="Picture 6" descr="image.png"/>
+          <p:cNvPr id="9" name="Picture 8" descr="image.png"/>
           <p:cNvPicPr>
             <a:picLocks noChangeAspect="1"/>
           </p:cNvPicPr>
@@ -24443,7 +24472,7 @@
       </p:pic>
       <p:sp>
         <p:nvSpPr>
-          <p:cNvPr id="8" name="TextBox 7"/>
+          <p:cNvPr id="10" name="TextBox 9"/>
           <p:cNvSpPr txBox="1"/>
           <p:nvPr/>
         </p:nvSpPr>

</xml_diff>

<commit_message>
Revert "Refresh Montgomery rebuild artifacts"
This reverts commit bedbafa039b41f676e8b164c0f2903ef9707df8c.
</commit_message>
<xml_diff>
--- a/deliverables/montgomery_crash_safety_presentation.pptx
+++ b/deliverables/montgomery_crash_safety_presentation.pptx
@@ -24417,38 +24417,9 @@
           </a:p>
         </p:txBody>
       </p:sp>
-      <p:sp>
-        <p:nvSpPr>
-          <p:cNvPr id="8" name="TextBox 7"/>
-          <p:cNvSpPr txBox="1"/>
-          <p:nvPr/>
-        </p:nvSpPr>
-        <p:spPr>
-          <a:xfrm>
-            <a:off x="502920" y="228600"/>
-            <a:ext cx="11064240" cy="502920"/>
-          </a:xfrm>
-          <a:prstGeom prst="rect">
-            <a:avLst/>
-          </a:prstGeom>
-          <a:noFill/>
-        </p:spPr>
-        <p:txBody>
-          <a:bodyPr wrap="none">
-            <a:spAutoFit/>
-          </a:bodyPr>
-          <a:lstStyle/>
-          <a:p>
-            <a:r>
-              <a:rPr sz="2400" b="1"/>
-              <a:t>CEI disadvantaged tracts and priority corridors</a:t>
-            </a:r>
-          </a:p>
-        </p:txBody>
-      </p:sp>
       <p:pic>
         <p:nvPicPr>
-          <p:cNvPr id="9" name="Picture 8" descr="image.png"/>
+          <p:cNvPr id="7" name="Picture 6" descr="image.png"/>
           <p:cNvPicPr>
             <a:picLocks noChangeAspect="1"/>
           </p:cNvPicPr>
@@ -24472,7 +24443,7 @@
       </p:pic>
       <p:sp>
         <p:nvSpPr>
-          <p:cNvPr id="10" name="TextBox 9"/>
+          <p:cNvPr id="8" name="TextBox 7"/>
           <p:cNvSpPr txBox="1"/>
           <p:nvPr/>
         </p:nvSpPr>

</xml_diff>

<commit_message>
Revert "Polish Montgomery crash safety portfolio"
This reverts commit a18c0e0d223bcb050ffb9a9122892dc5525307d5.
</commit_message>
<xml_diff>
--- a/deliverables/montgomery_crash_safety_presentation.pptx
+++ b/deliverables/montgomery_crash_safety_presentation.pptx
@@ -20424,26 +20424,82 @@
       </p:sp>
       <p:pic>
         <p:nvPicPr>
-          <p:cNvPr id="3" name="Picture 2" descr="image.png"/>
+          <p:cNvPr id="1026" name="Picture 2" descr="A graph of a bar chart&#10;&#10;AI-generated content may be incorrect.">
+            <a:extLst>
+              <a:ext uri="{FF2B5EF4-FFF2-40B4-BE49-F238E27FC236}">
+                <a16:creationId xmlns:a16="http://schemas.microsoft.com/office/drawing/2014/main" id="{ABC592DF-C7E7-703F-A94E-E09B7A0AFD23}"/>
+              </a:ext>
+            </a:extLst>
+          </p:cNvPr>
+          <p:cNvPicPr>
+            <a:picLocks noChangeAspect="1" noChangeArrowheads="1"/>
+          </p:cNvPicPr>
+          <p:nvPr/>
+        </p:nvPicPr>
+        <p:blipFill>
+          <a:blip r:embed="rId2">
+            <a:extLst>
+              <a:ext uri="{28A0092B-C50C-407E-A947-70E740481C1C}">
+                <a14:useLocalDpi xmlns:a14="http://schemas.microsoft.com/office/drawing/2010/main" val="0"/>
+              </a:ext>
+            </a:extLst>
+          </a:blip>
+          <a:srcRect t="569" r="4" b="4"/>
+          <a:stretch>
+            <a:fillRect/>
+          </a:stretch>
+        </p:blipFill>
+        <p:spPr bwMode="auto">
+          <a:xfrm>
+            <a:off x="713200" y="1177406"/>
+            <a:ext cx="3858775" cy="3433958"/>
+          </a:xfrm>
+          <a:prstGeom prst="rect">
+            <a:avLst/>
+          </a:prstGeom>
+          <a:solidFill>
+            <a:srgbClr val="FFFFFF"/>
+          </a:solidFill>
+          <a:ln>
+            <a:noFill/>
+          </a:ln>
+        </p:spPr>
+      </p:pic>
+      <p:pic>
+        <p:nvPicPr>
+          <p:cNvPr id="4" name="Picture 3" descr="A group of people riding bicycles on a crosswalk&#10;&#10;AI-generated content may be incorrect.">
+            <a:extLst>
+              <a:ext uri="{FF2B5EF4-FFF2-40B4-BE49-F238E27FC236}">
+                <a16:creationId xmlns:a16="http://schemas.microsoft.com/office/drawing/2014/main" id="{C3878E93-D56C-5706-B036-C445F233AE76}"/>
+              </a:ext>
+            </a:extLst>
+          </p:cNvPr>
           <p:cNvPicPr>
             <a:picLocks noChangeAspect="1"/>
           </p:cNvPicPr>
           <p:nvPr/>
         </p:nvPicPr>
         <p:blipFill>
-          <a:blip r:embed="rId4"/>
+          <a:blip r:embed="rId3"/>
+          <a:srcRect l="16702" r="8289" b="-2"/>
           <a:stretch>
             <a:fillRect/>
           </a:stretch>
         </p:blipFill>
         <p:spPr>
           <a:xfrm>
-            <a:off x="685800" y="1234440"/>
-            <a:ext cx="10835640" cy="5888803"/>
+            <a:off x="5148775" y="1434067"/>
+            <a:ext cx="3281950" cy="2920636"/>
           </a:xfrm>
           <a:prstGeom prst="rect">
             <a:avLst/>
           </a:prstGeom>
+          <a:noFill/>
+          <a:ln w="19050">
+            <a:solidFill>
+              <a:schemeClr val="accent6"/>
+            </a:solidFill>
+          </a:ln>
         </p:spPr>
       </p:pic>
     </p:spTree>
@@ -20520,6 +20576,86 @@
           </a:p>
         </p:txBody>
       </p:sp>
+      <p:pic>
+        <p:nvPicPr>
+          <p:cNvPr id="2052" name="Picture 4" descr="A graph of a bar chart&#10;&#10;AI-generated content may be incorrect.">
+            <a:extLst>
+              <a:ext uri="{FF2B5EF4-FFF2-40B4-BE49-F238E27FC236}">
+                <a16:creationId xmlns:a16="http://schemas.microsoft.com/office/drawing/2014/main" id="{87747C02-C72B-5B11-9776-ACC2647D3E1B}"/>
+              </a:ext>
+            </a:extLst>
+          </p:cNvPr>
+          <p:cNvPicPr>
+            <a:picLocks noChangeAspect="1" noChangeArrowheads="1"/>
+          </p:cNvPicPr>
+          <p:nvPr/>
+        </p:nvPicPr>
+        <p:blipFill>
+          <a:blip r:embed="rId2">
+            <a:extLst>
+              <a:ext uri="{28A0092B-C50C-407E-A947-70E740481C1C}">
+                <a14:useLocalDpi xmlns:a14="http://schemas.microsoft.com/office/drawing/2010/main" val="0"/>
+              </a:ext>
+            </a:extLst>
+          </a:blip>
+          <a:srcRect r="4" b="850"/>
+          <a:stretch>
+            <a:fillRect/>
+          </a:stretch>
+        </p:blipFill>
+        <p:spPr bwMode="auto">
+          <a:xfrm>
+            <a:off x="713207" y="1208225"/>
+            <a:ext cx="3858768" cy="3433952"/>
+          </a:xfrm>
+          <a:prstGeom prst="rect">
+            <a:avLst/>
+          </a:prstGeom>
+          <a:solidFill>
+            <a:srgbClr val="FFFFFF"/>
+          </a:solidFill>
+          <a:ln>
+            <a:noFill/>
+          </a:ln>
+        </p:spPr>
+      </p:pic>
+      <p:pic>
+        <p:nvPicPr>
+          <p:cNvPr id="5" name="Picture 4" descr="A person sitting in a car with an object in his hand&#10;&#10;AI-generated content may be incorrect.">
+            <a:extLst>
+              <a:ext uri="{FF2B5EF4-FFF2-40B4-BE49-F238E27FC236}">
+                <a16:creationId xmlns:a16="http://schemas.microsoft.com/office/drawing/2014/main" id="{32F78D9E-4541-8BB5-2C15-665FA265D916}"/>
+              </a:ext>
+            </a:extLst>
+          </p:cNvPr>
+          <p:cNvPicPr>
+            <a:picLocks noChangeAspect="1"/>
+          </p:cNvPicPr>
+          <p:nvPr/>
+        </p:nvPicPr>
+        <p:blipFill>
+          <a:blip r:embed="rId3"/>
+          <a:srcRect l="1371" r="23620" b="-2"/>
+          <a:stretch>
+            <a:fillRect/>
+          </a:stretch>
+        </p:blipFill>
+        <p:spPr>
+          <a:xfrm>
+            <a:off x="5152933" y="1466733"/>
+            <a:ext cx="3277792" cy="2916936"/>
+          </a:xfrm>
+          <a:prstGeom prst="rect">
+            <a:avLst/>
+          </a:prstGeom>
+          <a:noFill/>
+          <a:ln w="19050">
+            <a:solidFill>
+              <a:schemeClr val="accent6"/>
+            </a:solidFill>
+          </a:ln>
+        </p:spPr>
+      </p:pic>
       <p:sp>
         <p:nvSpPr>
           <p:cNvPr id="3" name="Rectangle 2">
@@ -20572,30 +20708,6 @@
           </a:p>
         </p:txBody>
       </p:sp>
-      <p:pic>
-        <p:nvPicPr>
-          <p:cNvPr id="4" name="Picture 3" descr="image.png"/>
-          <p:cNvPicPr>
-            <a:picLocks noChangeAspect="1"/>
-          </p:cNvPicPr>
-          <p:nvPr/>
-        </p:nvPicPr>
-        <p:blipFill>
-          <a:blip r:embed="rId4"/>
-          <a:stretch>
-            <a:fillRect/>
-          </a:stretch>
-        </p:blipFill>
-        <p:spPr>
-          <a:xfrm>
-            <a:off x="685800" y="1234440"/>
-            <a:ext cx="10835640" cy="5892107"/>
-          </a:xfrm>
-          <a:prstGeom prst="rect">
-            <a:avLst/>
-          </a:prstGeom>
-        </p:spPr>
-      </p:pic>
     </p:spTree>
     <p:extLst>
       <p:ext uri="{BB962C8B-B14F-4D97-AF65-F5344CB8AC3E}">
@@ -20670,7 +20782,7 @@
                 </a:solidFill>
                 <a:latin typeface="Vidaloka" panose="020B0604020202020204" charset="0"/>
               </a:rPr>
-              <a:t>Limited resources require focused safety investment</a:t>
+              <a:t>As Resources Are Limited So As People’s Attention</a:t>
             </a:r>
           </a:p>
         </p:txBody>
@@ -21087,26 +21199,37 @@
       </p:grpSpPr>
       <p:pic>
         <p:nvPicPr>
-          <p:cNvPr id="2" name="Picture 1" descr="image.png"/>
+          <p:cNvPr id="4" name="Picture 3">
+            <a:extLst>
+              <a:ext uri="{FF2B5EF4-FFF2-40B4-BE49-F238E27FC236}">
+                <a16:creationId xmlns:a16="http://schemas.microsoft.com/office/drawing/2014/main" id="{6EE50979-7842-F7E8-0DB1-3859158FBED0}"/>
+              </a:ext>
+            </a:extLst>
+          </p:cNvPr>
           <p:cNvPicPr>
             <a:picLocks noChangeAspect="1"/>
           </p:cNvPicPr>
           <p:nvPr/>
         </p:nvPicPr>
         <p:blipFill>
-          <a:blip r:embed="rId3"/>
+          <a:blip r:embed="rId2"/>
           <a:stretch>
             <a:fillRect/>
           </a:stretch>
         </p:blipFill>
         <p:spPr>
           <a:xfrm>
-            <a:off x="274320" y="640080"/>
-            <a:ext cx="8595360" cy="7780931"/>
+            <a:off x="1852432" y="373242"/>
+            <a:ext cx="5439136" cy="4397016"/>
           </a:xfrm>
           <a:prstGeom prst="rect">
             <a:avLst/>
           </a:prstGeom>
+          <a:ln w="19050">
+            <a:solidFill>
+              <a:schemeClr val="accent6"/>
+            </a:solidFill>
+          </a:ln>
         </p:spPr>
       </p:pic>
     </p:spTree>
@@ -21252,26 +21375,54 @@
       </p:sp>
       <p:pic>
         <p:nvPicPr>
-          <p:cNvPr id="3" name="Picture 2" descr="image.png"/>
+          <p:cNvPr id="3074" name="Picture 2">
+            <a:extLst>
+              <a:ext uri="{FF2B5EF4-FFF2-40B4-BE49-F238E27FC236}">
+                <a16:creationId xmlns:a16="http://schemas.microsoft.com/office/drawing/2014/main" id="{F8444BAB-0F4F-B769-1285-EBB7AAEF41D9}"/>
+              </a:ext>
+            </a:extLst>
+          </p:cNvPr>
           <p:cNvPicPr>
-            <a:picLocks noChangeAspect="1"/>
+            <a:picLocks noChangeAspect="1" noChangeArrowheads="1"/>
           </p:cNvPicPr>
           <p:nvPr/>
         </p:nvPicPr>
         <p:blipFill>
-          <a:blip r:embed="rId3"/>
+          <a:blip r:embed="rId2">
+            <a:extLst>
+              <a:ext uri="{28A0092B-C50C-407E-A947-70E740481C1C}">
+                <a14:useLocalDpi xmlns:a14="http://schemas.microsoft.com/office/drawing/2010/main" val="0"/>
+              </a:ext>
+            </a:extLst>
+          </a:blip>
+          <a:srcRect/>
           <a:stretch>
             <a:fillRect/>
           </a:stretch>
         </p:blipFill>
-        <p:spPr>
+        <p:spPr bwMode="auto">
           <a:xfrm>
-            <a:off x="685800" y="1234440"/>
-            <a:ext cx="10835640" cy="5898728"/>
+            <a:off x="4154503" y="492722"/>
+            <a:ext cx="4757380" cy="4158055"/>
           </a:xfrm>
           <a:prstGeom prst="rect">
             <a:avLst/>
           </a:prstGeom>
+          <a:noFill/>
+          <a:ln w="19050">
+            <a:solidFill>
+              <a:schemeClr val="accent6"/>
+            </a:solidFill>
+          </a:ln>
+          <a:extLst>
+            <a:ext uri="{909E8E84-426E-40DD-AFC4-6F175D3DCCD1}">
+              <a14:hiddenFill xmlns:a14="http://schemas.microsoft.com/office/drawing/2010/main">
+                <a:solidFill>
+                  <a:srgbClr val="FFFFFF"/>
+                </a:solidFill>
+              </a14:hiddenFill>
+            </a:ext>
+          </a:extLst>
         </p:spPr>
       </p:pic>
     </p:spTree>
@@ -21337,6 +21488,53 @@
           </a:p>
         </p:txBody>
       </p:sp>
+      <p:pic>
+        <p:nvPicPr>
+          <p:cNvPr id="4102" name="Picture 6">
+            <a:extLst>
+              <a:ext uri="{FF2B5EF4-FFF2-40B4-BE49-F238E27FC236}">
+                <a16:creationId xmlns:a16="http://schemas.microsoft.com/office/drawing/2014/main" id="{67135E3F-216D-4CA2-7FEC-F1BB547199F2}"/>
+              </a:ext>
+            </a:extLst>
+          </p:cNvPr>
+          <p:cNvPicPr>
+            <a:picLocks noChangeAspect="1" noChangeArrowheads="1"/>
+          </p:cNvPicPr>
+          <p:nvPr/>
+        </p:nvPicPr>
+        <p:blipFill>
+          <a:blip r:embed="rId2">
+            <a:extLst>
+              <a:ext uri="{28A0092B-C50C-407E-A947-70E740481C1C}">
+                <a14:useLocalDpi xmlns:a14="http://schemas.microsoft.com/office/drawing/2010/main" val="0"/>
+              </a:ext>
+            </a:extLst>
+          </a:blip>
+          <a:srcRect/>
+          <a:stretch>
+            <a:fillRect/>
+          </a:stretch>
+        </p:blipFill>
+        <p:spPr bwMode="auto">
+          <a:xfrm>
+            <a:off x="1090246" y="1017725"/>
+            <a:ext cx="7737231" cy="3825631"/>
+          </a:xfrm>
+          <a:prstGeom prst="rect">
+            <a:avLst/>
+          </a:prstGeom>
+          <a:noFill/>
+          <a:extLst>
+            <a:ext uri="{909E8E84-426E-40DD-AFC4-6F175D3DCCD1}">
+              <a14:hiddenFill xmlns:a14="http://schemas.microsoft.com/office/drawing/2010/main">
+                <a:solidFill>
+                  <a:srgbClr val="FFFFFF"/>
+                </a:solidFill>
+              </a14:hiddenFill>
+            </a:ext>
+          </a:extLst>
+        </p:spPr>
+      </p:pic>
       <p:sp>
         <p:nvSpPr>
           <p:cNvPr id="4" name="Rectangle 3">
@@ -21390,30 +21588,6 @@
           </a:p>
         </p:txBody>
       </p:sp>
-      <p:pic>
-        <p:nvPicPr>
-          <p:cNvPr id="5" name="Picture 4" descr="image.png"/>
-          <p:cNvPicPr>
-            <a:picLocks noChangeAspect="1"/>
-          </p:cNvPicPr>
-          <p:nvPr/>
-        </p:nvPicPr>
-        <p:blipFill>
-          <a:blip r:embed="rId3"/>
-          <a:stretch>
-            <a:fillRect/>
-          </a:stretch>
-        </p:blipFill>
-        <p:spPr>
-          <a:xfrm>
-            <a:off x="685800" y="1234440"/>
-            <a:ext cx="10835640" cy="5627719"/>
-          </a:xfrm>
-          <a:prstGeom prst="rect">
-            <a:avLst/>
-          </a:prstGeom>
-        </p:spPr>
-      </p:pic>
     </p:spTree>
     <p:extLst>
       <p:ext uri="{BB962C8B-B14F-4D97-AF65-F5344CB8AC3E}">
@@ -21568,6 +21742,53 @@
           </a:p>
         </p:txBody>
       </p:sp>
+      <p:pic>
+        <p:nvPicPr>
+          <p:cNvPr id="5130" name="Picture 10">
+            <a:extLst>
+              <a:ext uri="{FF2B5EF4-FFF2-40B4-BE49-F238E27FC236}">
+                <a16:creationId xmlns:a16="http://schemas.microsoft.com/office/drawing/2014/main" id="{F82210AF-5FD1-836F-4A98-FE8A9CC4CBCB}"/>
+              </a:ext>
+            </a:extLst>
+          </p:cNvPr>
+          <p:cNvPicPr>
+            <a:picLocks noChangeAspect="1" noChangeArrowheads="1"/>
+          </p:cNvPicPr>
+          <p:nvPr/>
+        </p:nvPicPr>
+        <p:blipFill>
+          <a:blip r:embed="rId2">
+            <a:extLst>
+              <a:ext uri="{28A0092B-C50C-407E-A947-70E740481C1C}">
+                <a14:useLocalDpi xmlns:a14="http://schemas.microsoft.com/office/drawing/2010/main" val="0"/>
+              </a:ext>
+            </a:extLst>
+          </a:blip>
+          <a:srcRect/>
+          <a:stretch>
+            <a:fillRect/>
+          </a:stretch>
+        </p:blipFill>
+        <p:spPr bwMode="auto">
+          <a:xfrm>
+            <a:off x="713225" y="1027958"/>
+            <a:ext cx="7441809" cy="3670517"/>
+          </a:xfrm>
+          <a:prstGeom prst="rect">
+            <a:avLst/>
+          </a:prstGeom>
+          <a:noFill/>
+          <a:extLst>
+            <a:ext uri="{909E8E84-426E-40DD-AFC4-6F175D3DCCD1}">
+              <a14:hiddenFill xmlns:a14="http://schemas.microsoft.com/office/drawing/2010/main">
+                <a:solidFill>
+                  <a:srgbClr val="FFFFFF"/>
+                </a:solidFill>
+              </a14:hiddenFill>
+            </a:ext>
+          </a:extLst>
+        </p:spPr>
+      </p:pic>
       <p:sp>
         <p:nvSpPr>
           <p:cNvPr id="4" name="Rectangle 3">
@@ -21649,30 +21870,6 @@
           </a:graphicData>
         </a:graphic>
       </p:graphicFrame>
-      <p:pic>
-        <p:nvPicPr>
-          <p:cNvPr id="7" name="Picture 6" descr="image.png"/>
-          <p:cNvPicPr>
-            <a:picLocks noChangeAspect="1"/>
-          </p:cNvPicPr>
-          <p:nvPr/>
-        </p:nvPicPr>
-        <p:blipFill>
-          <a:blip r:embed="rId8"/>
-          <a:stretch>
-            <a:fillRect/>
-          </a:stretch>
-        </p:blipFill>
-        <p:spPr>
-          <a:xfrm>
-            <a:off x="685800" y="1234440"/>
-            <a:ext cx="10835640" cy="5905363"/>
-          </a:xfrm>
-          <a:prstGeom prst="rect">
-            <a:avLst/>
-          </a:prstGeom>
-        </p:spPr>
-      </p:pic>
     </p:spTree>
     <p:extLst>
       <p:ext uri="{BB962C8B-B14F-4D97-AF65-F5344CB8AC3E}">
@@ -23402,7 +23599,7 @@
                 </a:solidFill>
                 <a:latin typeface="Vidaloka" panose="020B0604020202020204" charset="0"/>
               </a:rPr>
-              <a:t>Priority scoring adds equity and vulnerable users</a:t>
+              <a:t>Now We Need to Consider (Equity &amp; Vulnerable Users)</a:t>
             </a:r>
           </a:p>
         </p:txBody>
@@ -23591,7 +23788,22 @@
           <a:lstStyle/>
           <a:p>
             <a:r>
-              <a:t>KSI crash burden</a:t>
+              <a:rPr lang="en-US" dirty="0">
+                <a:solidFill>
+                  <a:srgbClr val="FF0000"/>
+                </a:solidFill>
+                <a:latin typeface="Vidaloka" panose="020B0604020202020204" charset="0"/>
+              </a:rPr>
+              <a:t>Fatal &amp; severe </a:t>
+            </a:r>
+            <a:r>
+              <a:rPr lang="en-US" dirty="0">
+                <a:solidFill>
+                  <a:schemeClr val="tx1"/>
+                </a:solidFill>
+                <a:latin typeface="Vidaloka" panose="020B0604020202020204" charset="0"/>
+              </a:rPr>
+              <a:t>collisions</a:t>
             </a:r>
           </a:p>
         </p:txBody>
@@ -23625,7 +23837,34 @@
           <a:lstStyle/>
           <a:p>
             <a:r>
-              <a:t>(1.00 x KSI burden)</a:t>
+              <a:rPr lang="en-US" dirty="0">
+                <a:latin typeface="Vidaloka" panose="020B0604020202020204" charset="0"/>
+              </a:rPr>
+              <a:t>(0.5 x </a:t>
+            </a:r>
+            <a:r>
+              <a:rPr lang="en-US" dirty="0">
+                <a:solidFill>
+                  <a:srgbClr val="FF0000"/>
+                </a:solidFill>
+                <a:latin typeface="Vidaloka" panose="020B0604020202020204" charset="0"/>
+              </a:rPr>
+              <a:t>Fatal </a:t>
+            </a:r>
+            <a:r>
+              <a:rPr lang="en-US" dirty="0">
+                <a:solidFill>
+                  <a:schemeClr val="tx1"/>
+                </a:solidFill>
+                <a:latin typeface="Vidaloka" panose="020B0604020202020204" charset="0"/>
+              </a:rPr>
+              <a:t>collisions</a:t>
+            </a:r>
+            <a:r>
+              <a:rPr lang="en-US" dirty="0">
+                <a:latin typeface="Vidaloka" panose="020B0604020202020204" charset="0"/>
+              </a:rPr>
+              <a:t>)</a:t>
             </a:r>
           </a:p>
         </p:txBody>
@@ -23659,7 +23898,31 @@
           <a:lstStyle/>
           <a:p>
             <a:r>
-              <a:t>(0.50 x VRU KSI)</a:t>
+              <a:rPr lang="en-US" dirty="0">
+                <a:solidFill>
+                  <a:schemeClr val="tx1"/>
+                </a:solidFill>
+                <a:latin typeface="Vidaloka" panose="020B0604020202020204" charset="0"/>
+              </a:rPr>
+              <a:t>(0.25 x </a:t>
+            </a:r>
+            <a:r>
+              <a:rPr lang="en-US" dirty="0">
+                <a:solidFill>
+                  <a:srgbClr val="FF0000"/>
+                </a:solidFill>
+                <a:latin typeface="Vidaloka" panose="020B0604020202020204" charset="0"/>
+              </a:rPr>
+              <a:t>Vulnerable Users </a:t>
+            </a:r>
+            <a:r>
+              <a:rPr lang="en-US" dirty="0">
+                <a:solidFill>
+                  <a:schemeClr val="tx1"/>
+                </a:solidFill>
+                <a:latin typeface="Vidaloka" panose="020B0604020202020204" charset="0"/>
+              </a:rPr>
+              <a:t>collisions)  </a:t>
             </a:r>
           </a:p>
         </p:txBody>
@@ -23693,7 +23956,48 @@
           <a:lstStyle/>
           <a:p>
             <a:r>
-              <a:t>(0.25 x KSI in disadvantaged tracts)</a:t>
+              <a:rPr lang="en-US" dirty="0">
+                <a:solidFill>
+                  <a:schemeClr val="tx1"/>
+                </a:solidFill>
+                <a:latin typeface="Vidaloka" panose="020B0604020202020204" charset="0"/>
+              </a:rPr>
+              <a:t>(0.25 x </a:t>
+            </a:r>
+            <a:r>
+              <a:rPr lang="en-US" dirty="0">
+                <a:latin typeface="Vidaloka" panose="020B0604020202020204" charset="0"/>
+              </a:rPr>
+              <a:t>Fatal &amp; severe collisions</a:t>
+            </a:r>
+          </a:p>
+          <a:p>
+            <a:r>
+              <a:rPr lang="en-US" dirty="0">
+                <a:solidFill>
+                  <a:schemeClr val="tx1"/>
+                </a:solidFill>
+                <a:latin typeface="Vidaloka" panose="020B0604020202020204" charset="0"/>
+              </a:rPr>
+              <a:t>In </a:t>
+            </a:r>
+            <a:r>
+              <a:rPr lang="en-US" dirty="0">
+                <a:solidFill>
+                  <a:srgbClr val="FF0000"/>
+                </a:solidFill>
+                <a:latin typeface="Vidaloka" panose="020B0604020202020204" charset="0"/>
+              </a:rPr>
+              <a:t>disadvantaged areas</a:t>
+            </a:r>
+            <a:r>
+              <a:rPr lang="en-US" dirty="0">
+                <a:solidFill>
+                  <a:schemeClr val="tx1"/>
+                </a:solidFill>
+                <a:latin typeface="Vidaloka" panose="020B0604020202020204" charset="0"/>
+              </a:rPr>
+              <a:t>)</a:t>
             </a:r>
           </a:p>
         </p:txBody>
@@ -23873,8 +24177,12 @@
           </a:bodyPr>
           <a:lstStyle/>
           <a:p>
+            <a:pPr algn="ctr"/>
             <a:r>
-              <a:t>(0.25 x exposure-adjusted risk)</a:t>
+              <a:rPr lang="en-US" dirty="0">
+                <a:latin typeface="Vidaloka" panose="020B0604020202020204" charset="0"/>
+              </a:rPr>
+              <a:t>Segment length</a:t>
             </a:r>
           </a:p>
         </p:txBody>
@@ -23994,11 +24302,58 @@
           <a:p>
             <a:r>
               <a:rPr lang="en-US" dirty="0"/>
-              <a:t>Top 10 Segments by CEI-aware priority score</a:t>
+              <a:t>Top 10 Segments by composite score</a:t>
             </a:r>
           </a:p>
         </p:txBody>
       </p:sp>
+      <p:pic>
+        <p:nvPicPr>
+          <p:cNvPr id="6152" name="Picture 8">
+            <a:extLst>
+              <a:ext uri="{FF2B5EF4-FFF2-40B4-BE49-F238E27FC236}">
+                <a16:creationId xmlns:a16="http://schemas.microsoft.com/office/drawing/2014/main" id="{1032F073-5CB7-6812-F56E-48876A031E85}"/>
+              </a:ext>
+            </a:extLst>
+          </p:cNvPr>
+          <p:cNvPicPr>
+            <a:picLocks noChangeAspect="1" noChangeArrowheads="1"/>
+          </p:cNvPicPr>
+          <p:nvPr/>
+        </p:nvPicPr>
+        <p:blipFill>
+          <a:blip r:embed="rId2">
+            <a:extLst>
+              <a:ext uri="{28A0092B-C50C-407E-A947-70E740481C1C}">
+                <a14:useLocalDpi xmlns:a14="http://schemas.microsoft.com/office/drawing/2010/main" val="0"/>
+              </a:ext>
+            </a:extLst>
+          </a:blip>
+          <a:srcRect/>
+          <a:stretch>
+            <a:fillRect/>
+          </a:stretch>
+        </p:blipFill>
+        <p:spPr bwMode="auto">
+          <a:xfrm>
+            <a:off x="926329" y="1093337"/>
+            <a:ext cx="7291292" cy="3605138"/>
+          </a:xfrm>
+          <a:prstGeom prst="rect">
+            <a:avLst/>
+          </a:prstGeom>
+          <a:noFill/>
+          <a:extLst>
+            <a:ext uri="{909E8E84-426E-40DD-AFC4-6F175D3DCCD1}">
+              <a14:hiddenFill xmlns:a14="http://schemas.microsoft.com/office/drawing/2010/main">
+                <a:solidFill>
+                  <a:srgbClr val="FFFFFF"/>
+                </a:solidFill>
+              </a14:hiddenFill>
+            </a:ext>
+          </a:extLst>
+        </p:spPr>
+      </p:pic>
       <p:sp>
         <p:nvSpPr>
           <p:cNvPr id="7" name="Rectangle 6">
@@ -24263,30 +24618,6 @@
           </a:p>
         </p:txBody>
       </p:sp>
-      <p:pic>
-        <p:nvPicPr>
-          <p:cNvPr id="8" name="Picture 7" descr="image.png"/>
-          <p:cNvPicPr>
-            <a:picLocks noChangeAspect="1"/>
-          </p:cNvPicPr>
-          <p:nvPr/>
-        </p:nvPicPr>
-        <p:blipFill>
-          <a:blip r:embed="rId3"/>
-          <a:stretch>
-            <a:fillRect/>
-          </a:stretch>
-        </p:blipFill>
-        <p:spPr>
-          <a:xfrm>
-            <a:off x="685800" y="1234440"/>
-            <a:ext cx="10835640" cy="5877164"/>
-          </a:xfrm>
-          <a:prstGeom prst="rect">
-            <a:avLst/>
-          </a:prstGeom>
-        </p:spPr>
-      </p:pic>
     </p:spTree>
     <p:extLst>
       <p:ext uri="{BB962C8B-B14F-4D97-AF65-F5344CB8AC3E}">
@@ -24359,117 +24690,6 @@
           </a:graphicData>
         </a:graphic>
       </p:graphicFrame>
-      <p:sp>
-        <p:nvSpPr>
-          <p:cNvPr id="4" name="TextBox 3"/>
-          <p:cNvSpPr txBox="1"/>
-          <p:nvPr/>
-        </p:nvSpPr>
-        <p:spPr>
-          <a:xfrm>
-            <a:off x="502920" y="228600"/>
-            <a:ext cx="11064240" cy="502920"/>
-          </a:xfrm>
-          <a:prstGeom prst="rect">
-            <a:avLst/>
-          </a:prstGeom>
-          <a:noFill/>
-        </p:spPr>
-        <p:txBody>
-          <a:bodyPr wrap="none">
-            <a:spAutoFit/>
-          </a:bodyPr>
-          <a:lstStyle/>
-          <a:p>
-            <a:r>
-              <a:rPr sz="2400" b="1"/>
-              <a:t>CEI disadvantaged tracts and priority corridors</a:t>
-            </a:r>
-          </a:p>
-        </p:txBody>
-      </p:sp>
-      <p:sp>
-        <p:nvSpPr>
-          <p:cNvPr id="6" name="TextBox 5"/>
-          <p:cNvSpPr txBox="1"/>
-          <p:nvPr/>
-        </p:nvSpPr>
-        <p:spPr>
-          <a:xfrm>
-            <a:off x="502920" y="228600"/>
-            <a:ext cx="11064240" cy="502920"/>
-          </a:xfrm>
-          <a:prstGeom prst="rect">
-            <a:avLst/>
-          </a:prstGeom>
-          <a:noFill/>
-        </p:spPr>
-        <p:txBody>
-          <a:bodyPr wrap="none">
-            <a:spAutoFit/>
-          </a:bodyPr>
-          <a:lstStyle/>
-          <a:p>
-            <a:r>
-              <a:rPr sz="2400" b="1"/>
-              <a:t>CEI disadvantaged tracts and priority corridors</a:t>
-            </a:r>
-          </a:p>
-        </p:txBody>
-      </p:sp>
-      <p:pic>
-        <p:nvPicPr>
-          <p:cNvPr id="7" name="Picture 6" descr="image.png"/>
-          <p:cNvPicPr>
-            <a:picLocks noChangeAspect="1"/>
-          </p:cNvPicPr>
-          <p:nvPr/>
-        </p:nvPicPr>
-        <p:blipFill>
-          <a:blip r:embed="rId7"/>
-          <a:stretch>
-            <a:fillRect/>
-          </a:stretch>
-        </p:blipFill>
-        <p:spPr>
-          <a:xfrm>
-            <a:off x="274320" y="640080"/>
-            <a:ext cx="8595360" cy="7560508"/>
-          </a:xfrm>
-          <a:prstGeom prst="rect">
-            <a:avLst/>
-          </a:prstGeom>
-        </p:spPr>
-      </p:pic>
-      <p:sp>
-        <p:nvSpPr>
-          <p:cNvPr id="8" name="TextBox 7"/>
-          <p:cNvSpPr txBox="1"/>
-          <p:nvPr/>
-        </p:nvSpPr>
-        <p:spPr>
-          <a:xfrm>
-            <a:off x="502920" y="228600"/>
-            <a:ext cx="11064240" cy="502920"/>
-          </a:xfrm>
-          <a:prstGeom prst="rect">
-            <a:avLst/>
-          </a:prstGeom>
-          <a:noFill/>
-        </p:spPr>
-        <p:txBody>
-          <a:bodyPr wrap="none">
-            <a:spAutoFit/>
-          </a:bodyPr>
-          <a:lstStyle/>
-          <a:p>
-            <a:r>
-              <a:rPr sz="2400" b="1"/>
-              <a:t>CEI disadvantaged tracts and priority corridors</a:t>
-            </a:r>
-          </a:p>
-        </p:txBody>
-      </p:sp>
     </p:spTree>
     <p:extLst>
       <p:ext uri="{BB962C8B-B14F-4D97-AF65-F5344CB8AC3E}">
@@ -24792,41 +25012,180 @@
           </a:bodyPr>
           <a:lstStyle/>
           <a:p>
+            <a:pPr marL="285750" indent="-285750">
+              <a:buFont typeface="Arial" panose="020B0604020202020204" pitchFamily="34" charset="0"/>
+              <a:buChar char="•"/>
+            </a:pPr>
             <a:r>
-              <a:t>Prioritizes high-harm corridors, including corridors in disadvantaged tracts</a:t>
+              <a:rPr lang="en-US" sz="1800" dirty="0">
+                <a:solidFill>
+                  <a:srgbClr val="FF0000"/>
+                </a:solidFill>
+                <a:latin typeface="Vidaloka" panose="020B0604020202020204" charset="0"/>
+              </a:rPr>
+              <a:t>Ensures fairness </a:t>
+            </a:r>
+            <a:r>
+              <a:rPr lang="en-US" sz="1800" dirty="0">
+                <a:latin typeface="Vidaloka" panose="020B0604020202020204" charset="0"/>
+              </a:rPr>
+              <a:t>– not just big arterials, also smaller risky roads</a:t>
             </a:r>
           </a:p>
-          <a:p/>
           <a:p>
+            <a:pPr marL="285750" indent="-285750">
+              <a:buFont typeface="Arial" panose="020B0604020202020204" pitchFamily="34" charset="0"/>
+              <a:buChar char="•"/>
+            </a:pPr>
+            <a:endParaRPr lang="en-US" sz="1800" dirty="0">
+              <a:latin typeface="Vidaloka" panose="020B0604020202020204" charset="0"/>
+            </a:endParaRPr>
+          </a:p>
+          <a:p>
+            <a:pPr marL="285750" indent="-285750">
+              <a:buFont typeface="Arial" panose="020B0604020202020204" pitchFamily="34" charset="0"/>
+              <a:buChar char="•"/>
+            </a:pPr>
             <a:r>
-              <a:t>Re-score every 2-3 years</a:t>
+              <a:rPr lang="en-US" sz="1800" dirty="0">
+                <a:solidFill>
+                  <a:srgbClr val="FF0000"/>
+                </a:solidFill>
+                <a:latin typeface="Vidaloka" panose="020B0604020202020204" charset="0"/>
+              </a:rPr>
+              <a:t>Re-score</a:t>
+            </a:r>
+            <a:r>
+              <a:rPr lang="en-US" sz="1800" dirty="0">
+                <a:latin typeface="Vidaloka" panose="020B0604020202020204" charset="0"/>
+              </a:rPr>
+              <a:t> every 2–3 years</a:t>
             </a:r>
           </a:p>
-          <a:p/>
           <a:p>
+            <a:pPr marL="285750" indent="-285750">
+              <a:buFont typeface="Arial" panose="020B0604020202020204" pitchFamily="34" charset="0"/>
+              <a:buChar char="•"/>
+            </a:pPr>
+            <a:endParaRPr lang="en-US" sz="1800" dirty="0">
+              <a:latin typeface="Vidaloka" panose="020B0604020202020204" charset="0"/>
+            </a:endParaRPr>
+          </a:p>
+          <a:p>
+            <a:pPr marL="285750" indent="-285750">
+              <a:buFont typeface="Arial" panose="020B0604020202020204" pitchFamily="34" charset="0"/>
+              <a:buChar char="•"/>
+            </a:pPr>
             <a:r>
+              <a:rPr lang="en-US" sz="1800" dirty="0">
+                <a:latin typeface="Vidaloka" panose="020B0604020202020204" charset="0"/>
+              </a:rPr>
               <a:t>Phased delivery:</a:t>
             </a:r>
           </a:p>
           <a:p>
+            <a:pPr marL="285750" indent="-285750">
+              <a:buFont typeface="Arial" panose="020B0604020202020204" pitchFamily="34" charset="0"/>
+              <a:buChar char="•"/>
+            </a:pPr>
+            <a:endParaRPr lang="en-US" sz="1800" dirty="0">
+              <a:latin typeface="Vidaloka" panose="020B0604020202020204" charset="0"/>
+            </a:endParaRPr>
+          </a:p>
+          <a:p>
+            <a:pPr lvl="1"/>
             <a:r>
-              <a:t>Year 1: quick wins such as LPIs, daylighting, and pilot road diets</a:t>
+              <a:rPr lang="en-US" sz="1800" dirty="0">
+                <a:solidFill>
+                  <a:srgbClr val="FF0000"/>
+                </a:solidFill>
+                <a:latin typeface="Vidaloka" panose="020B0604020202020204" charset="0"/>
+              </a:rPr>
+              <a:t>	Year 1 </a:t>
+            </a:r>
+            <a:r>
+              <a:rPr lang="en-US" sz="1800" dirty="0">
+                <a:latin typeface="Vidaloka" panose="020B0604020202020204" charset="0"/>
+              </a:rPr>
+              <a:t>→ Quick wins (LPIs, daylighting, pilot road diets)</a:t>
             </a:r>
           </a:p>
           <a:p>
+            <a:endParaRPr lang="en-US" sz="1800" dirty="0">
+              <a:latin typeface="Vidaloka" panose="020B0604020202020204" charset="0"/>
+            </a:endParaRPr>
+          </a:p>
+          <a:p>
             <a:r>
-              <a:t>Years 1-3: corridor redesigns</a:t>
+              <a:rPr lang="en-US" sz="1800" dirty="0">
+                <a:solidFill>
+                  <a:srgbClr val="FF0000"/>
+                </a:solidFill>
+                <a:latin typeface="Vidaloka" panose="020B0604020202020204" charset="0"/>
+              </a:rPr>
+              <a:t>	Years 1–3 </a:t>
+            </a:r>
+            <a:r>
+              <a:rPr lang="en-US" sz="1800" dirty="0">
+                <a:latin typeface="Vidaloka" panose="020B0604020202020204" charset="0"/>
+              </a:rPr>
+              <a:t>→ Corridor redesigns</a:t>
             </a:r>
           </a:p>
           <a:p>
+            <a:pPr marL="285750" indent="-285750">
+              <a:buFont typeface="Arial" panose="020B0604020202020204" pitchFamily="34" charset="0"/>
+              <a:buChar char="•"/>
+            </a:pPr>
+            <a:endParaRPr lang="en-US" sz="1800" dirty="0">
+              <a:latin typeface="Vidaloka" panose="020B0604020202020204" charset="0"/>
+            </a:endParaRPr>
+          </a:p>
+          <a:p>
             <a:r>
-              <a:t>Years 3-5: major reconstructions</a:t>
+              <a:rPr lang="en-US" sz="1800" dirty="0">
+                <a:solidFill>
+                  <a:srgbClr val="FF0000"/>
+                </a:solidFill>
+                <a:latin typeface="Vidaloka" panose="020B0604020202020204" charset="0"/>
+              </a:rPr>
+              <a:t>	Years 3–5 </a:t>
+            </a:r>
+            <a:r>
+              <a:rPr lang="en-US" sz="1800" dirty="0">
+                <a:latin typeface="Vidaloka" panose="020B0604020202020204" charset="0"/>
+              </a:rPr>
+              <a:t>→ Major reconstructions</a:t>
             </a:r>
           </a:p>
-          <a:p/>
           <a:p>
+            <a:pPr marL="285750" indent="-285750">
+              <a:buFont typeface="Arial" panose="020B0604020202020204" pitchFamily="34" charset="0"/>
+              <a:buChar char="•"/>
+            </a:pPr>
+            <a:endParaRPr lang="en-US" sz="1800" dirty="0">
+              <a:latin typeface="Vidaloka" panose="020B0604020202020204" charset="0"/>
+            </a:endParaRPr>
+          </a:p>
+          <a:p>
+            <a:pPr marL="285750" indent="-285750">
+              <a:buFont typeface="Arial" panose="020B0604020202020204" pitchFamily="34" charset="0"/>
+              <a:buChar char="•"/>
+            </a:pPr>
             <a:r>
-              <a:t>Track progress: KSI, HIN share, VRU KSI, CEI contribution, and exposure-adjusted risk</a:t>
+              <a:rPr lang="en-US" sz="1800" dirty="0">
+                <a:solidFill>
+                  <a:srgbClr val="FF0000"/>
+                </a:solidFill>
+                <a:latin typeface="Vidaloka" panose="020B0604020202020204" charset="0"/>
+              </a:rPr>
+              <a:t>Track progress</a:t>
+            </a:r>
+            <a:r>
+              <a:rPr lang="en-US" sz="1800" dirty="0">
+                <a:latin typeface="Vidaloka" panose="020B0604020202020204" charset="0"/>
+              </a:rPr>
+              <a:t>: KSI, HIN share, VRU, equity, cost</a:t>
             </a:r>
           </a:p>
         </p:txBody>
@@ -25194,7 +25553,7 @@
                   <a:schemeClr val="accent1"/>
                 </a:solidFill>
               </a:rPr>
-              <a:t>Problem Statement</a:t>
+              <a:t>Proplem Statement</a:t>
             </a:r>
             <a:endParaRPr b="1" dirty="0">
               <a:solidFill>
@@ -25461,9 +25820,211 @@
             </a:lvl9pPr>
           </a:lstStyle>
           <a:p>
+            <a:pPr marL="114300">
+              <a:lnSpc>
+                <a:spcPct val="150000"/>
+              </a:lnSpc>
+            </a:pPr>
             <a:r>
-              <a:t>From 2020-2024, Montgomery County recorded 59,476 crashes. Of these, 1,400 were fatal or suspected serious injury crashes (KSI), with an estimated $7.1 billion in societal cost. To reach Vision Zero, the County should focus engineering, enforcement, and policy on the corridors and conditions most strongly linked to severe crashes.</a:t>
+              <a:rPr lang="en-US" sz="1800" dirty="0">
+                <a:latin typeface="Vidaloka" panose="020B0604020202020204" charset="0"/>
+              </a:rPr>
+              <a:t>From </a:t>
             </a:r>
+            <a:r>
+              <a:rPr lang="en-US" sz="1800" b="1" dirty="0">
+                <a:latin typeface="Vidaloka" panose="020B0604020202020204" charset="0"/>
+              </a:rPr>
+              <a:t>2020–2024</a:t>
+            </a:r>
+            <a:r>
+              <a:rPr lang="en-US" sz="1800" dirty="0">
+                <a:latin typeface="Vidaloka" panose="020B0604020202020204" charset="0"/>
+              </a:rPr>
+              <a:t>, Montgomery County recorded </a:t>
+            </a:r>
+            <a:r>
+              <a:rPr lang="en-US" sz="1800" b="1" dirty="0">
+                <a:solidFill>
+                  <a:srgbClr val="FF0000"/>
+                </a:solidFill>
+                <a:latin typeface="Vidaloka" panose="020B0604020202020204" charset="0"/>
+              </a:rPr>
+              <a:t>113K total crashes</a:t>
+            </a:r>
+            <a:r>
+              <a:rPr lang="en-US" sz="1800" dirty="0">
+                <a:latin typeface="Vidaloka" panose="020B0604020202020204" charset="0"/>
+              </a:rPr>
+              <a:t>. Of these,</a:t>
+            </a:r>
+            <a:r>
+              <a:rPr lang="en-US" sz="1800" b="1" dirty="0">
+                <a:latin typeface="Vidaloka" panose="020B0604020202020204" charset="0"/>
+              </a:rPr>
+              <a:t> </a:t>
+            </a:r>
+            <a:r>
+              <a:rPr lang="en-US" sz="1800" b="1" dirty="0">
+                <a:solidFill>
+                  <a:srgbClr val="FF0000"/>
+                </a:solidFill>
+                <a:latin typeface="Vidaloka" panose="020B0604020202020204" charset="0"/>
+              </a:rPr>
+              <a:t>(4K crashes)</a:t>
+            </a:r>
+            <a:r>
+              <a:rPr lang="en-US" sz="1800" dirty="0">
+                <a:solidFill>
+                  <a:srgbClr val="FF0000"/>
+                </a:solidFill>
+                <a:latin typeface="Vidaloka" panose="020B0604020202020204" charset="0"/>
+              </a:rPr>
+              <a:t> </a:t>
+            </a:r>
+            <a:r>
+              <a:rPr lang="en-US" sz="1800" dirty="0">
+                <a:latin typeface="Vidaloka" panose="020B0604020202020204" charset="0"/>
+              </a:rPr>
+              <a:t>involved </a:t>
+            </a:r>
+            <a:r>
+              <a:rPr lang="en-US" sz="1800" b="1" dirty="0">
+                <a:solidFill>
+                  <a:srgbClr val="FF0000"/>
+                </a:solidFill>
+                <a:latin typeface="Vidaloka" panose="020B0604020202020204" charset="0"/>
+              </a:rPr>
+              <a:t>fatalities or serious injuries </a:t>
+            </a:r>
+            <a:r>
+              <a:rPr lang="en-US" sz="1800" dirty="0">
+                <a:latin typeface="Vidaloka" panose="020B0604020202020204" charset="0"/>
+              </a:rPr>
+              <a:t>(</a:t>
+            </a:r>
+            <a:r>
+              <a:rPr lang="en-US" sz="1800" b="1" dirty="0">
+                <a:latin typeface="Vidaloka" panose="020B0604020202020204" charset="0"/>
+              </a:rPr>
+              <a:t>KSI</a:t>
+            </a:r>
+            <a:r>
+              <a:rPr lang="en-US" sz="1800" dirty="0">
+                <a:latin typeface="Vidaloka" panose="020B0604020202020204" charset="0"/>
+              </a:rPr>
+              <a:t>), at an estimated </a:t>
+            </a:r>
+            <a:r>
+              <a:rPr lang="en-US" sz="1800" b="1" dirty="0">
+                <a:solidFill>
+                  <a:srgbClr val="FF0000"/>
+                </a:solidFill>
+                <a:latin typeface="Vidaloka" panose="020B0604020202020204" charset="0"/>
+              </a:rPr>
+              <a:t>$6.3 billion</a:t>
+            </a:r>
+            <a:r>
+              <a:rPr lang="en-US" sz="1800" dirty="0">
+                <a:solidFill>
+                  <a:srgbClr val="FF0000"/>
+                </a:solidFill>
+                <a:latin typeface="Vidaloka" panose="020B0604020202020204" charset="0"/>
+              </a:rPr>
+              <a:t> </a:t>
+            </a:r>
+            <a:r>
+              <a:rPr lang="en-US" sz="1800" dirty="0">
+                <a:latin typeface="Vidaloka" panose="020B0604020202020204" charset="0"/>
+              </a:rPr>
+              <a:t>in societal cost.</a:t>
+            </a:r>
+          </a:p>
+          <a:p>
+            <a:pPr marL="114300">
+              <a:lnSpc>
+                <a:spcPct val="150000"/>
+              </a:lnSpc>
+            </a:pPr>
+            <a:endParaRPr lang="en-US" sz="1800" dirty="0">
+              <a:latin typeface="Vidaloka" panose="020B0604020202020204" charset="0"/>
+            </a:endParaRPr>
+          </a:p>
+          <a:p>
+            <a:pPr marL="114300">
+              <a:lnSpc>
+                <a:spcPct val="150000"/>
+              </a:lnSpc>
+            </a:pPr>
+            <a:r>
+              <a:rPr lang="en-US" sz="1800" dirty="0">
+                <a:latin typeface="Vidaloka" panose="020B0604020202020204" charset="0"/>
+              </a:rPr>
+              <a:t>To reach </a:t>
+            </a:r>
+            <a:r>
+              <a:rPr lang="en-US" sz="1800" b="1" dirty="0">
+                <a:latin typeface="Vidaloka" panose="020B0604020202020204" charset="0"/>
+              </a:rPr>
+              <a:t>Vision Zero</a:t>
+            </a:r>
+            <a:r>
+              <a:rPr lang="en-US" sz="1800" dirty="0">
+                <a:latin typeface="Vidaloka" panose="020B0604020202020204" charset="0"/>
+              </a:rPr>
+              <a:t>, the County must </a:t>
+            </a:r>
+            <a:r>
+              <a:rPr lang="en-US" sz="1800" b="1" dirty="0">
+                <a:latin typeface="Vidaloka" panose="020B0604020202020204" charset="0"/>
+              </a:rPr>
+              <a:t>focus enforcement, engineering, and policy</a:t>
+            </a:r>
+            <a:r>
+              <a:rPr lang="en-US" sz="1800" dirty="0">
+                <a:latin typeface="Vidaloka" panose="020B0604020202020204" charset="0"/>
+              </a:rPr>
+              <a:t> on the </a:t>
+            </a:r>
+            <a:r>
+              <a:rPr lang="en-US" sz="1800" b="1" dirty="0">
+                <a:latin typeface="Vidaloka" panose="020B0604020202020204" charset="0"/>
+              </a:rPr>
+              <a:t>corridors and conditions most strongly linked to severe crashes</a:t>
+            </a:r>
+            <a:r>
+              <a:rPr lang="en-US" sz="1800" dirty="0">
+                <a:latin typeface="Vidaloka" panose="020B0604020202020204" charset="0"/>
+              </a:rPr>
+              <a:t>, to drive down both </a:t>
+            </a:r>
+            <a:r>
+              <a:rPr lang="en-US" sz="1800" b="1" dirty="0">
+                <a:latin typeface="Vidaloka" panose="020B0604020202020204" charset="0"/>
+              </a:rPr>
+              <a:t>lives lost</a:t>
+            </a:r>
+            <a:r>
+              <a:rPr lang="en-US" sz="1800" dirty="0">
+                <a:latin typeface="Vidaloka" panose="020B0604020202020204" charset="0"/>
+              </a:rPr>
+              <a:t> and </a:t>
+            </a:r>
+            <a:r>
+              <a:rPr lang="en-US" sz="1800" b="1" dirty="0">
+                <a:latin typeface="Vidaloka" panose="020B0604020202020204" charset="0"/>
+              </a:rPr>
+              <a:t>economic cost</a:t>
+            </a:r>
+            <a:r>
+              <a:rPr lang="en-US" sz="1800" dirty="0">
+                <a:latin typeface="Vidaloka" panose="020B0604020202020204" charset="0"/>
+              </a:rPr>
+              <a:t>.</a:t>
+            </a:r>
+            <a:endParaRPr lang="en-US" sz="2800" dirty="0">
+              <a:latin typeface="Vidaloka" panose="020B0604020202020204" charset="0"/>
+            </a:endParaRPr>
           </a:p>
         </p:txBody>
       </p:sp>
@@ -25896,6 +26457,53 @@
           </a:p>
         </p:txBody>
       </p:sp>
+      <p:pic>
+        <p:nvPicPr>
+          <p:cNvPr id="20482" name="Picture 2">
+            <a:extLst>
+              <a:ext uri="{FF2B5EF4-FFF2-40B4-BE49-F238E27FC236}">
+                <a16:creationId xmlns:a16="http://schemas.microsoft.com/office/drawing/2014/main" id="{D187E795-6EFC-19C1-D5E0-D6A9E468A5F2}"/>
+              </a:ext>
+            </a:extLst>
+          </p:cNvPr>
+          <p:cNvPicPr>
+            <a:picLocks noChangeAspect="1" noChangeArrowheads="1"/>
+          </p:cNvPicPr>
+          <p:nvPr/>
+        </p:nvPicPr>
+        <p:blipFill>
+          <a:blip r:embed="rId2">
+            <a:extLst>
+              <a:ext uri="{28A0092B-C50C-407E-A947-70E740481C1C}">
+                <a14:useLocalDpi xmlns:a14="http://schemas.microsoft.com/office/drawing/2010/main" val="0"/>
+              </a:ext>
+            </a:extLst>
+          </a:blip>
+          <a:srcRect/>
+          <a:stretch>
+            <a:fillRect/>
+          </a:stretch>
+        </p:blipFill>
+        <p:spPr bwMode="auto">
+          <a:xfrm>
+            <a:off x="0" y="1568450"/>
+            <a:ext cx="9144000" cy="3575050"/>
+          </a:xfrm>
+          <a:prstGeom prst="rect">
+            <a:avLst/>
+          </a:prstGeom>
+          <a:noFill/>
+          <a:extLst>
+            <a:ext uri="{909E8E84-426E-40DD-AFC4-6F175D3DCCD1}">
+              <a14:hiddenFill xmlns:a14="http://schemas.microsoft.com/office/drawing/2010/main">
+                <a:solidFill>
+                  <a:srgbClr val="FFFFFF"/>
+                </a:solidFill>
+              </a14:hiddenFill>
+            </a:ext>
+          </a:extLst>
+        </p:spPr>
+      </p:pic>
       <p:sp>
         <p:nvSpPr>
           <p:cNvPr id="3" name="Rectangle 2">
@@ -25949,30 +26557,6 @@
           </a:p>
         </p:txBody>
       </p:sp>
-      <p:pic>
-        <p:nvPicPr>
-          <p:cNvPr id="4" name="Picture 3" descr="image.png"/>
-          <p:cNvPicPr>
-            <a:picLocks noChangeAspect="1"/>
-          </p:cNvPicPr>
-          <p:nvPr/>
-        </p:nvPicPr>
-        <p:blipFill>
-          <a:blip r:embed="rId3"/>
-          <a:stretch>
-            <a:fillRect/>
-          </a:stretch>
-        </p:blipFill>
-        <p:spPr>
-          <a:xfrm>
-            <a:off x="685800" y="1234440"/>
-            <a:ext cx="10835640" cy="5904815"/>
-          </a:xfrm>
-          <a:prstGeom prst="rect">
-            <a:avLst/>
-          </a:prstGeom>
-        </p:spPr>
-      </p:pic>
     </p:spTree>
     <p:extLst>
       <p:ext uri="{BB962C8B-B14F-4D97-AF65-F5344CB8AC3E}">
@@ -26581,6 +27165,53 @@
           </a:p>
         </p:txBody>
       </p:sp>
+      <p:pic>
+        <p:nvPicPr>
+          <p:cNvPr id="2058" name="Picture 10">
+            <a:extLst>
+              <a:ext uri="{FF2B5EF4-FFF2-40B4-BE49-F238E27FC236}">
+                <a16:creationId xmlns:a16="http://schemas.microsoft.com/office/drawing/2014/main" id="{9EF3A103-545A-96AF-D0C9-FB4A75CC02D0}"/>
+              </a:ext>
+            </a:extLst>
+          </p:cNvPr>
+          <p:cNvPicPr>
+            <a:picLocks noChangeAspect="1" noChangeArrowheads="1"/>
+          </p:cNvPicPr>
+          <p:nvPr/>
+        </p:nvPicPr>
+        <p:blipFill>
+          <a:blip r:embed="rId2">
+            <a:extLst>
+              <a:ext uri="{28A0092B-C50C-407E-A947-70E740481C1C}">
+                <a14:useLocalDpi xmlns:a14="http://schemas.microsoft.com/office/drawing/2010/main" val="0"/>
+              </a:ext>
+            </a:extLst>
+          </a:blip>
+          <a:srcRect/>
+          <a:stretch>
+            <a:fillRect/>
+          </a:stretch>
+        </p:blipFill>
+        <p:spPr bwMode="auto">
+          <a:xfrm>
+            <a:off x="0" y="1374775"/>
+            <a:ext cx="9144000" cy="3768725"/>
+          </a:xfrm>
+          <a:prstGeom prst="rect">
+            <a:avLst/>
+          </a:prstGeom>
+          <a:noFill/>
+          <a:extLst>
+            <a:ext uri="{909E8E84-426E-40DD-AFC4-6F175D3DCCD1}">
+              <a14:hiddenFill xmlns:a14="http://schemas.microsoft.com/office/drawing/2010/main">
+                <a:solidFill>
+                  <a:srgbClr val="FFFFFF"/>
+                </a:solidFill>
+              </a14:hiddenFill>
+            </a:ext>
+          </a:extLst>
+        </p:spPr>
+      </p:pic>
       <p:sp>
         <p:nvSpPr>
           <p:cNvPr id="3" name="Rectangle 2">
@@ -26634,30 +27265,6 @@
           </a:p>
         </p:txBody>
       </p:sp>
-      <p:pic>
-        <p:nvPicPr>
-          <p:cNvPr id="4" name="Picture 3" descr="image.png"/>
-          <p:cNvPicPr>
-            <a:picLocks noChangeAspect="1"/>
-          </p:cNvPicPr>
-          <p:nvPr/>
-        </p:nvPicPr>
-        <p:blipFill>
-          <a:blip r:embed="rId3"/>
-          <a:stretch>
-            <a:fillRect/>
-          </a:stretch>
-        </p:blipFill>
-        <p:spPr>
-          <a:xfrm>
-            <a:off x="685800" y="1234440"/>
-            <a:ext cx="10835640" cy="5892107"/>
-          </a:xfrm>
-          <a:prstGeom prst="rect">
-            <a:avLst/>
-          </a:prstGeom>
-        </p:spPr>
-      </p:pic>
     </p:spTree>
     <p:extLst>
       <p:ext uri="{BB962C8B-B14F-4D97-AF65-F5344CB8AC3E}">

</xml_diff>